<commit_message>
Add Stephen Yeung as Partner, KFH pitch deck
</commit_message>
<xml_diff>
--- a/resources/KFH-Data-Strategy-Enterprise-AI.pptx
+++ b/resources/KFH-Data-Strategy-Enterprise-AI.pptx
@@ -4,9 +4,6 @@
   <p:sldMasterIdLst>
     <p:sldMasterId id="2147483648" r:id="rId1"/>
   </p:sldMasterIdLst>
-  <p:notesMasterIdLst>
-    <p:notesMasterId r:id="rId12"/>
-  </p:notesMasterIdLst>
   <p:sldIdLst>
     <p:sldId id="256" r:id="rId2"/>
     <p:sldId id="257" r:id="rId3"/>
@@ -19,7 +16,10 @@
     <p:sldId id="264" r:id="rId10"/>
     <p:sldId id="265" r:id="rId11"/>
   </p:sldIdLst>
-  <p:sldSz cx="9144000" cy="5143500" type="screen16x9"/>
+  <p:notesMasterIdLst>
+    <p:notesMasterId r:id="rId12"/>
+  </p:notesMasterIdLst>
+  <p:sldSz cx="9144000" cy="5143500"/>
   <p:notesSz cx="5143500" cy="9144000"/>
   <p:defaultTextStyle>
     <a:lvl1pPr marL="0" algn="l" defTabSz="914400" rtl="0" eaLnBrk="1" latinLnBrk="0" hangingPunct="1">
@@ -113,57 +113,7 @@
       </a:defRPr>
     </a:lvl9pPr>
   </p:defaultTextStyle>
-  <p:extLst>
-    <p:ext uri="{EFAFB233-063F-42B5-8137-9DF3F51BA10A}">
-      <p15:sldGuideLst xmlns:p15="http://schemas.microsoft.com/office/powerpoint/2012/main"/>
-    </p:ext>
-  </p:extLst>
 </p:presentation>
-</file>
-
-<file path=ppt/changesInfos/changesInfo1.xml><?xml version="1.0" encoding="utf-8"?>
-<pc:chgInfo xmlns:a="http://schemas.openxmlformats.org/drawingml/2006/main" xmlns:r="http://schemas.openxmlformats.org/officeDocument/2006/relationships" xmlns:ac="http://schemas.microsoft.com/office/drawing/2013/main/command" xmlns:pc="http://schemas.microsoft.com/office/powerpoint/2013/main/command">
-  <pc:docChgLst>
-    <pc:chgData name="Rodney Coutinho" userId="209a889691aee9f3" providerId="LiveId" clId="{77A27777-7345-430D-B1E1-F7BAFB49B08C}"/>
-    <pc:docChg chg="modSld">
-      <pc:chgData name="Rodney Coutinho" userId="209a889691aee9f3" providerId="LiveId" clId="{77A27777-7345-430D-B1E1-F7BAFB49B08C}" dt="2026-05-12T05:05:05.859" v="30" actId="20577"/>
-      <pc:docMkLst>
-        <pc:docMk/>
-      </pc:docMkLst>
-      <pc:sldChg chg="modSp mod">
-        <pc:chgData name="Rodney Coutinho" userId="209a889691aee9f3" providerId="LiveId" clId="{77A27777-7345-430D-B1E1-F7BAFB49B08C}" dt="2026-05-12T05:05:05.859" v="30" actId="20577"/>
-        <pc:sldMkLst>
-          <pc:docMk/>
-          <pc:sldMk cId="0" sldId="265"/>
-        </pc:sldMkLst>
-        <pc:spChg chg="mod">
-          <ac:chgData name="Rodney Coutinho" userId="209a889691aee9f3" providerId="LiveId" clId="{77A27777-7345-430D-B1E1-F7BAFB49B08C}" dt="2026-05-12T05:05:05.859" v="30" actId="20577"/>
-          <ac:spMkLst>
-            <pc:docMk/>
-            <pc:sldMk cId="0" sldId="265"/>
-            <ac:spMk id="12" creationId="{00000000-0000-0000-0000-000000000000}"/>
-          </ac:spMkLst>
-        </pc:spChg>
-        <pc:picChg chg="mod">
-          <ac:chgData name="Rodney Coutinho" userId="209a889691aee9f3" providerId="LiveId" clId="{77A27777-7345-430D-B1E1-F7BAFB49B08C}" dt="2026-05-12T05:04:11.488" v="2" actId="1076"/>
-          <ac:picMkLst>
-            <pc:docMk/>
-            <pc:sldMk cId="0" sldId="265"/>
-            <ac:picMk id="10" creationId="{00000000-0000-0000-0000-000000000000}"/>
-          </ac:picMkLst>
-        </pc:picChg>
-        <pc:picChg chg="mod">
-          <ac:chgData name="Rodney Coutinho" userId="209a889691aee9f3" providerId="LiveId" clId="{77A27777-7345-430D-B1E1-F7BAFB49B08C}" dt="2026-05-12T05:04:06.004" v="1" actId="1076"/>
-          <ac:picMkLst>
-            <pc:docMk/>
-            <pc:sldMk cId="0" sldId="265"/>
-            <ac:picMk id="13" creationId="{00000000-0000-0000-0000-000000000000}"/>
-          </ac:picMkLst>
-        </pc:picChg>
-      </pc:sldChg>
-    </pc:docChg>
-  </pc:docChgLst>
-</pc:chgInfo>
 </file>
 
 <file path=ppt/notesMasters/notesMaster1.xml><?xml version="1.0" encoding="utf-8"?>
@@ -188,10 +138,234 @@
           <a:chExt cx="0" cy="0"/>
         </a:xfrm>
       </p:grpSpPr>
+      <p:sp>
+        <p:nvSpPr>
+          <p:cNvPr id="2" name="Header Placeholder 1"/>
+          <p:cNvSpPr>
+            <a:spLocks noGrp="1"/>
+          </p:cNvSpPr>
+          <p:nvPr>
+            <p:ph type="hdr" sz="quarter"/>
+          </p:nvPr>
+        </p:nvSpPr>
+        <p:spPr>
+          <a:xfrm>
+            <a:off x="0" y="0"/>
+            <a:ext cx="2971800" cy="458788"/>
+          </a:xfrm>
+          <a:prstGeom prst="rect">
+            <a:avLst/>
+          </a:prstGeom>
+        </p:spPr>
+        <p:txBody>
+          <a:bodyPr vert="horz" lIns="91440" tIns="45720" rIns="91440" bIns="45720" rtlCol="0"/>
+          <a:lstStyle>
+            <a:lvl1pPr algn="l">
+              <a:defRPr sz="1200"/>
+            </a:lvl1pPr>
+          </a:lstStyle>
+          <a:p>
+            <a:endParaRPr lang="en-US"/>
+          </a:p>
+        </p:txBody>
+      </p:sp>
+      <p:sp>
+        <p:nvSpPr>
+          <p:cNvPr id="3" name="Date Placeholder 2"/>
+          <p:cNvSpPr>
+            <a:spLocks noGrp="1"/>
+          </p:cNvSpPr>
+          <p:nvPr>
+            <p:ph type="dt" idx="1"/>
+          </p:nvPr>
+        </p:nvSpPr>
+        <p:spPr>
+          <a:xfrm>
+            <a:off x="3884613" y="0"/>
+            <a:ext cx="2971800" cy="458788"/>
+          </a:xfrm>
+          <a:prstGeom prst="rect">
+            <a:avLst/>
+          </a:prstGeom>
+        </p:spPr>
+        <p:txBody>
+          <a:bodyPr vert="horz" lIns="91440" tIns="45720" rIns="91440" bIns="45720" rtlCol="0"/>
+          <a:lstStyle>
+            <a:lvl1pPr algn="r">
+              <a:defRPr sz="1200"/>
+            </a:lvl1pPr>
+          </a:lstStyle>
+          <a:p>
+            <a:fld id="{5282F153-3F37-0F45-9E97-73ACFA13230C}" type="datetimeFigureOut">
+              <a:rPr lang="en-US"/>
+              <a:t>7/23/19</a:t>
+            </a:fld>
+            <a:endParaRPr lang="en-US"/>
+          </a:p>
+        </p:txBody>
+      </p:sp>
+      <p:sp>
+        <p:nvSpPr>
+          <p:cNvPr id="4" name="Slide Image Placeholder 3"/>
+          <p:cNvSpPr>
+            <a:spLocks noGrp="1" noRot="1" noChangeAspect="1"/>
+          </p:cNvSpPr>
+          <p:nvPr>
+            <p:ph type="sldImg" idx="2"/>
+          </p:nvPr>
+        </p:nvSpPr>
+        <p:spPr>
+          <a:xfrm>
+            <a:off x="685800" y="1143000"/>
+            <a:ext cx="5486400" cy="3086100"/>
+          </a:xfrm>
+          <a:prstGeom prst="rect">
+            <a:avLst/>
+          </a:prstGeom>
+          <a:noFill/>
+          <a:ln w="12700">
+            <a:solidFill>
+              <a:prstClr val="black"/>
+            </a:solidFill>
+          </a:ln>
+        </p:spPr>
+        <p:txBody>
+          <a:bodyPr vert="horz" lIns="91440" tIns="45720" rIns="91440" bIns="45720" rtlCol="0" anchor="ctr"/>
+          <a:lstStyle/>
+          <a:p>
+            <a:endParaRPr lang="en-US"/>
+          </a:p>
+        </p:txBody>
+      </p:sp>
+      <p:sp>
+        <p:nvSpPr>
+          <p:cNvPr id="5" name="Notes Placeholder 4"/>
+          <p:cNvSpPr>
+            <a:spLocks noGrp="1"/>
+          </p:cNvSpPr>
+          <p:nvPr>
+            <p:ph type="body" sz="quarter" idx="3"/>
+          </p:nvPr>
+        </p:nvSpPr>
+        <p:spPr>
+          <a:xfrm>
+            <a:off x="685800" y="4400550"/>
+            <a:ext cx="5486400" cy="3600450"/>
+          </a:xfrm>
+          <a:prstGeom prst="rect">
+            <a:avLst/>
+          </a:prstGeom>
+        </p:spPr>
+        <p:txBody>
+          <a:bodyPr vert="horz" lIns="91440" tIns="45720" rIns="91440" bIns="45720" rtlCol="0"/>
+          <a:lstStyle/>
+          <a:p>
+            <a:pPr lvl="0"/>
+            <a:r>
+              <a:rPr lang="en-US"/>
+              <a:t>Click to edit Master text styles</a:t>
+            </a:r>
+          </a:p>
+          <a:p>
+            <a:pPr lvl="1"/>
+            <a:r>
+              <a:rPr lang="en-US"/>
+              <a:t>Second level</a:t>
+            </a:r>
+          </a:p>
+          <a:p>
+            <a:pPr lvl="2"/>
+            <a:r>
+              <a:rPr lang="en-US"/>
+              <a:t>Third level</a:t>
+            </a:r>
+          </a:p>
+          <a:p>
+            <a:pPr lvl="3"/>
+            <a:r>
+              <a:rPr lang="en-US"/>
+              <a:t>Fourth level</a:t>
+            </a:r>
+          </a:p>
+          <a:p>
+            <a:pPr lvl="4"/>
+            <a:r>
+              <a:rPr lang="en-US"/>
+              <a:t>Fifth level</a:t>
+            </a:r>
+          </a:p>
+        </p:txBody>
+      </p:sp>
+      <p:sp>
+        <p:nvSpPr>
+          <p:cNvPr id="6" name="Footer Placeholder 5"/>
+          <p:cNvSpPr>
+            <a:spLocks noGrp="1"/>
+          </p:cNvSpPr>
+          <p:nvPr>
+            <p:ph type="ftr" sz="quarter" idx="4"/>
+          </p:nvPr>
+        </p:nvSpPr>
+        <p:spPr>
+          <a:xfrm>
+            <a:off x="0" y="8685213"/>
+            <a:ext cx="2971800" cy="458787"/>
+          </a:xfrm>
+          <a:prstGeom prst="rect">
+            <a:avLst/>
+          </a:prstGeom>
+        </p:spPr>
+        <p:txBody>
+          <a:bodyPr vert="horz" lIns="91440" tIns="45720" rIns="91440" bIns="45720" rtlCol="0" anchor="b"/>
+          <a:lstStyle>
+            <a:lvl1pPr algn="l">
+              <a:defRPr sz="1200"/>
+            </a:lvl1pPr>
+          </a:lstStyle>
+          <a:p>
+            <a:endParaRPr lang="en-US"/>
+          </a:p>
+        </p:txBody>
+      </p:sp>
+      <p:sp>
+        <p:nvSpPr>
+          <p:cNvPr id="7" name="Slide Number Placeholder 6"/>
+          <p:cNvSpPr>
+            <a:spLocks noGrp="1"/>
+          </p:cNvSpPr>
+          <p:nvPr>
+            <p:ph type="sldNum" sz="quarter" idx="5"/>
+          </p:nvPr>
+        </p:nvSpPr>
+        <p:spPr>
+          <a:xfrm>
+            <a:off x="3884613" y="8685213"/>
+            <a:ext cx="2971800" cy="458787"/>
+          </a:xfrm>
+          <a:prstGeom prst="rect">
+            <a:avLst/>
+          </a:prstGeom>
+        </p:spPr>
+        <p:txBody>
+          <a:bodyPr vert="horz" lIns="91440" tIns="45720" rIns="91440" bIns="45720" rtlCol="0" anchor="b"/>
+          <a:lstStyle>
+            <a:lvl1pPr algn="r">
+              <a:defRPr sz="1200"/>
+            </a:lvl1pPr>
+          </a:lstStyle>
+          <a:p>
+            <a:fld id="{CE5E9CC1-C706-0F49-92D6-E571CC5EEA8F}" type="slidenum">
+              <a:rPr lang="en-US"/>
+              <a:t>‹#›</a:t>
+            </a:fld>
+            <a:endParaRPr lang="en-US"/>
+          </a:p>
+        </p:txBody>
+      </p:sp>
     </p:spTree>
     <p:extLst>
       <p:ext uri="{BB962C8B-B14F-4D97-AF65-F5344CB8AC3E}">
-        <p14:creationId xmlns:p14="http://schemas.microsoft.com/office/powerpoint/2010/main" val="373203866"/>
+        <p14:creationId xmlns:p14="http://schemas.microsoft.com/office/powerpoint/2010/main" val="1024086991"/>
       </p:ext>
     </p:extLst>
   </p:cSld>
@@ -335,6 +509,10 @@
           <a:bodyPr/>
           <a:lstStyle/>
           <a:p>
+            <a:r>
+              <a:rPr lang="en-US" dirty="0"/>
+              <a:t/>
+            </a:r>
             <a:endParaRPr lang="en-US" dirty="0"/>
           </a:p>
         </p:txBody>
@@ -419,6 +597,10 @@
           <a:bodyPr/>
           <a:lstStyle/>
           <a:p>
+            <a:r>
+              <a:rPr lang="en-US" dirty="0"/>
+              <a:t/>
+            </a:r>
             <a:endParaRPr lang="en-US" dirty="0"/>
           </a:p>
         </p:txBody>
@@ -503,6 +685,10 @@
           <a:bodyPr/>
           <a:lstStyle/>
           <a:p>
+            <a:r>
+              <a:rPr lang="en-US" dirty="0"/>
+              <a:t/>
+            </a:r>
             <a:endParaRPr lang="en-US" dirty="0"/>
           </a:p>
         </p:txBody>
@@ -587,6 +773,10 @@
           <a:bodyPr/>
           <a:lstStyle/>
           <a:p>
+            <a:r>
+              <a:rPr lang="en-US" dirty="0"/>
+              <a:t/>
+            </a:r>
             <a:endParaRPr lang="en-US" dirty="0"/>
           </a:p>
         </p:txBody>
@@ -671,6 +861,10 @@
           <a:bodyPr/>
           <a:lstStyle/>
           <a:p>
+            <a:r>
+              <a:rPr lang="en-US" dirty="0"/>
+              <a:t/>
+            </a:r>
             <a:endParaRPr lang="en-US" dirty="0"/>
           </a:p>
         </p:txBody>
@@ -755,6 +949,10 @@
           <a:bodyPr/>
           <a:lstStyle/>
           <a:p>
+            <a:r>
+              <a:rPr lang="en-US" dirty="0"/>
+              <a:t/>
+            </a:r>
             <a:endParaRPr lang="en-US" dirty="0"/>
           </a:p>
         </p:txBody>
@@ -839,6 +1037,10 @@
           <a:bodyPr/>
           <a:lstStyle/>
           <a:p>
+            <a:r>
+              <a:rPr lang="en-US" dirty="0"/>
+              <a:t/>
+            </a:r>
             <a:endParaRPr lang="en-US" dirty="0"/>
           </a:p>
         </p:txBody>
@@ -923,6 +1125,10 @@
           <a:bodyPr/>
           <a:lstStyle/>
           <a:p>
+            <a:r>
+              <a:rPr lang="en-US" dirty="0"/>
+              <a:t/>
+            </a:r>
             <a:endParaRPr lang="en-US" dirty="0"/>
           </a:p>
         </p:txBody>
@@ -1007,6 +1213,10 @@
           <a:bodyPr/>
           <a:lstStyle/>
           <a:p>
+            <a:r>
+              <a:rPr lang="en-US" dirty="0"/>
+              <a:t/>
+            </a:r>
             <a:endParaRPr lang="en-US" dirty="0"/>
           </a:p>
         </p:txBody>
@@ -1091,6 +1301,10 @@
           <a:bodyPr/>
           <a:lstStyle/>
           <a:p>
+            <a:r>
+              <a:rPr lang="en-US" dirty="0"/>
+              <a:t/>
+            </a:r>
             <a:endParaRPr lang="en-US" dirty="0"/>
           </a:p>
         </p:txBody>
@@ -1164,11 +1378,6 @@
 <file path=ppt/slideMasters/slideMaster1.xml><?xml version="1.0" encoding="utf-8"?>
 <p:sldMaster xmlns:a="http://schemas.openxmlformats.org/drawingml/2006/main" xmlns:r="http://schemas.openxmlformats.org/officeDocument/2006/relationships" xmlns:p="http://schemas.openxmlformats.org/presentationml/2006/main">
   <p:cSld>
-    <p:bg>
-      <p:bgRef idx="1001">
-        <a:schemeClr val="bg1"/>
-      </p:bgRef>
-    </p:bg>
     <p:spTree>
       <p:nvGrpSpPr>
         <p:cNvPr id="1" name=""/>
@@ -1451,7 +1660,6 @@
         <a:solidFill>
           <a:srgbClr val="0D1B2A"/>
         </a:solidFill>
-        <a:effectLst/>
       </p:bgPr>
     </p:bg>
     <p:spTree>
@@ -1489,13 +1697,6 @@
           </a:solidFill>
           <a:ln/>
         </p:spPr>
-        <p:txBody>
-          <a:bodyPr/>
-          <a:lstStyle/>
-          <a:p>
-            <a:endParaRPr lang="en-AE"/>
-          </a:p>
-        </p:txBody>
       </p:sp>
       <p:sp>
         <p:nvSpPr>
@@ -1518,13 +1719,6 @@
           </a:solidFill>
           <a:ln/>
         </p:spPr>
-        <p:txBody>
-          <a:bodyPr/>
-          <a:lstStyle/>
-          <a:p>
-            <a:endParaRPr lang="en-AE"/>
-          </a:p>
-        </p:txBody>
       </p:sp>
       <p:sp>
         <p:nvSpPr>
@@ -1547,7 +1741,7 @@
           <a:bodyPr wrap="square" rtlCol="0" anchor="ctr"/>
           <a:lstStyle/>
           <a:p>
-            <a:pPr marL="0" indent="0">
+            <a:pPr indent="0" marL="0">
               <a:buNone/>
             </a:pPr>
             <a:r>
@@ -1561,6 +1755,9 @@
               </a:rPr>
               <a:t>Enterprise</a:t>
             </a:r>
+            <a:pPr indent="0" marL="0">
+              <a:buNone/>
+            </a:pPr>
             <a:r>
               <a:rPr lang="en-US" sz="1400" b="1" dirty="0">
                 <a:solidFill>
@@ -1597,7 +1794,7 @@
           <a:bodyPr wrap="square" lIns="0" tIns="0" rIns="0" bIns="0" rtlCol="0" anchor="ctr"/>
           <a:lstStyle/>
           <a:p>
-            <a:pPr marL="0" indent="0">
+            <a:pPr indent="0" marL="0">
               <a:buNone/>
             </a:pPr>
             <a:r>
@@ -1636,7 +1833,7 @@
           <a:bodyPr wrap="square" lIns="0" tIns="0" rIns="0" bIns="0" rtlCol="0" anchor="ctr"/>
           <a:lstStyle/>
           <a:p>
-            <a:pPr marL="0" indent="0">
+            <a:pPr indent="0" marL="0">
               <a:buNone/>
             </a:pPr>
             <a:r>
@@ -1653,7 +1850,7 @@
             <a:endParaRPr lang="en-US" sz="3600" dirty="0"/>
           </a:p>
           <a:p>
-            <a:pPr marL="0" indent="0">
+            <a:pPr indent="0" marL="0">
               <a:buNone/>
             </a:pPr>
             <a:r>
@@ -1693,13 +1890,6 @@
             <a:prstDash val="solid"/>
           </a:ln>
         </p:spPr>
-        <p:txBody>
-          <a:bodyPr/>
-          <a:lstStyle/>
-          <a:p>
-            <a:endParaRPr lang="en-AE"/>
-          </a:p>
-        </p:txBody>
       </p:sp>
       <p:sp>
         <p:nvSpPr>
@@ -1722,7 +1912,7 @@
           <a:bodyPr wrap="square" rtlCol="0" anchor="ctr"/>
           <a:lstStyle/>
           <a:p>
-            <a:pPr marL="0" indent="0">
+            <a:pPr indent="0" marL="0">
               <a:buNone/>
             </a:pPr>
             <a:r>
@@ -1761,7 +1951,7 @@
           <a:bodyPr wrap="square" rtlCol="0" anchor="ctr"/>
           <a:lstStyle/>
           <a:p>
-            <a:pPr marL="0" indent="0">
+            <a:pPr indent="0" marL="0">
               <a:buNone/>
             </a:pPr>
             <a:r>
@@ -1800,13 +1990,6 @@
           </a:solidFill>
           <a:ln/>
         </p:spPr>
-        <p:txBody>
-          <a:bodyPr/>
-          <a:lstStyle/>
-          <a:p>
-            <a:endParaRPr lang="en-AE"/>
-          </a:p>
-        </p:txBody>
       </p:sp>
       <p:sp>
         <p:nvSpPr>
@@ -1829,11 +2012,11 @@
           <a:bodyPr wrap="square" rtlCol="0" anchor="ctr"/>
           <a:lstStyle/>
           <a:p>
-            <a:pPr marL="0" indent="0" algn="ctr">
-              <a:buNone/>
-            </a:pPr>
-            <a:r>
-              <a:rPr lang="en-US" sz="900" b="1" kern="0" spc="400" dirty="0">
+            <a:pPr algn="ctr" indent="0" marL="0">
+              <a:buNone/>
+            </a:pPr>
+            <a:r>
+              <a:rPr lang="en-US" sz="900" b="1" spc="400" kern="0" dirty="0">
                 <a:solidFill>
                   <a:srgbClr val="F5EDE0"/>
                 </a:solidFill>
@@ -1863,7 +2046,6 @@
         <a:solidFill>
           <a:srgbClr val="FAF6F1"/>
         </a:solidFill>
-        <a:effectLst/>
       </p:bgPr>
     </p:bg>
     <p:spTree>
@@ -1899,13 +2081,6 @@
           </a:solidFill>
           <a:ln/>
         </p:spPr>
-        <p:txBody>
-          <a:bodyPr/>
-          <a:lstStyle/>
-          <a:p>
-            <a:endParaRPr lang="en-AE"/>
-          </a:p>
-        </p:txBody>
       </p:sp>
       <p:sp>
         <p:nvSpPr>
@@ -1928,11 +2103,11 @@
           <a:bodyPr wrap="square" rtlCol="0" anchor="ctr"/>
           <a:lstStyle/>
           <a:p>
-            <a:pPr marL="0" indent="0" algn="ctr">
-              <a:buNone/>
-            </a:pPr>
-            <a:r>
-              <a:rPr lang="en-US" sz="800" b="1" kern="0" spc="300" dirty="0">
+            <a:pPr algn="ctr" indent="0" marL="0">
+              <a:buNone/>
+            </a:pPr>
+            <a:r>
+              <a:rPr lang="en-US" sz="800" b="1" spc="300" kern="0" dirty="0">
                 <a:solidFill>
                   <a:srgbClr val="F5EDE0"/>
                 </a:solidFill>
@@ -1967,11 +2142,11 @@
           <a:bodyPr wrap="square" rtlCol="0" anchor="ctr"/>
           <a:lstStyle/>
           <a:p>
-            <a:pPr marL="0" indent="0">
-              <a:buNone/>
-            </a:pPr>
-            <a:r>
-              <a:rPr lang="en-US" sz="900" b="1" kern="0" spc="300" dirty="0">
+            <a:pPr indent="0" marL="0">
+              <a:buNone/>
+            </a:pPr>
+            <a:r>
+              <a:rPr lang="en-US" sz="900" b="1" spc="300" kern="0" dirty="0">
                 <a:solidFill>
                   <a:srgbClr val="006B5E"/>
                 </a:solidFill>
@@ -2007,13 +2182,6 @@
             <a:prstDash val="solid"/>
           </a:ln>
         </p:spPr>
-        <p:txBody>
-          <a:bodyPr/>
-          <a:lstStyle/>
-          <a:p>
-            <a:endParaRPr lang="en-AE"/>
-          </a:p>
-        </p:txBody>
       </p:sp>
       <p:sp>
         <p:nvSpPr>
@@ -2036,7 +2204,7 @@
           <a:bodyPr wrap="square" lIns="0" tIns="0" rIns="0" bIns="0" rtlCol="0" anchor="ctr"/>
           <a:lstStyle/>
           <a:p>
-            <a:pPr marL="0" indent="0">
+            <a:pPr indent="0" marL="0">
               <a:buNone/>
             </a:pPr>
             <a:r>
@@ -2073,13 +2241,6 @@
           </a:solidFill>
           <a:ln/>
         </p:spPr>
-        <p:txBody>
-          <a:bodyPr/>
-          <a:lstStyle/>
-          <a:p>
-            <a:endParaRPr lang="en-AE"/>
-          </a:p>
-        </p:txBody>
       </p:sp>
       <p:sp>
         <p:nvSpPr>
@@ -2102,7 +2263,7 @@
           <a:bodyPr wrap="square" rtlCol="0" anchor="ctr"/>
           <a:lstStyle/>
           <a:p>
-            <a:pPr marL="0" indent="0">
+            <a:pPr indent="0" marL="0">
               <a:buNone/>
             </a:pPr>
             <a:r>
@@ -2141,7 +2302,7 @@
           <a:bodyPr wrap="square" rtlCol="0" anchor="ctr"/>
           <a:lstStyle/>
           <a:p>
-            <a:pPr marL="0" indent="0" algn="r">
+            <a:pPr algn="r" indent="0" marL="0">
               <a:buNone/>
             </a:pPr>
             <a:r>
@@ -2161,21 +2322,21 @@
       </p:sp>
       <p:pic>
         <p:nvPicPr>
-          <p:cNvPr id="10" name="Image 0" descr="/sessions/cool-elegant-cori/rodney_photo.png"/>
+          <p:cNvPr id="10" name="Image 0" descr="/sessions/cool-elegant-cori/stephen_photo.jpeg">    </p:cNvPr>
           <p:cNvPicPr>
             <a:picLocks noChangeAspect="1"/>
           </p:cNvPicPr>
           <p:nvPr/>
         </p:nvPicPr>
         <p:blipFill>
-          <a:blip r:embed="rId3"/>
+          <a:blip r:embed="rId1"/>
           <a:stretch>
             <a:fillRect/>
           </a:stretch>
         </p:blipFill>
         <p:spPr>
           <a:xfrm>
-            <a:off x="759406" y="3012980"/>
+            <a:off x="731520" y="1645920"/>
             <a:ext cx="1005840" cy="1005840"/>
           </a:xfrm>
           <a:prstGeom prst="ellipse">
@@ -2204,7 +2365,7 @@
           <a:bodyPr wrap="square" lIns="0" tIns="0" rIns="0" bIns="0" rtlCol="0" anchor="ctr"/>
           <a:lstStyle/>
           <a:p>
-            <a:pPr marL="0" indent="0">
+            <a:pPr indent="0" marL="0">
               <a:buNone/>
             </a:pPr>
             <a:r>
@@ -2243,7 +2404,7 @@
           <a:bodyPr wrap="square" lIns="0" tIns="0" rIns="0" bIns="0" rtlCol="0" anchor="ctr"/>
           <a:lstStyle/>
           <a:p>
-            <a:pPr marL="0" indent="0">
+            <a:pPr indent="0" marL="0">
               <a:lnSpc>
                 <a:spcPct val="140000"/>
               </a:lnSpc>
@@ -2258,7 +2419,7 @@
                 <a:ea typeface="Arial" pitchFamily="34" charset="-122"/>
                 <a:cs typeface="Arial" pitchFamily="34" charset="-120"/>
               </a:rPr>
-              <a:t>Partner-level AI and data advisory across Deloitte, EY, and global exchanges. 25+ years building, governing, and scaling AI and data platforms in financial services — from trading surveillance systems to sovereign AI programmes across the Gulf and UK. Board-level advisory on AI and Data strategy, governance, and enterprise adoption in the Middle East.</a:t>
+              <a:t>Partner-level AI and data advisory across Deloitte, EY, and global exchanges. 25+ years building, governing, and scaling AI and data platforms in financial services — from trading surveillance systems to sovereign AI programmes across the Gulf and UK. Board-level advisory on AI strategy, governance, and enterprise adoption.</a:t>
             </a:r>
             <a:endParaRPr lang="en-US" sz="1000" dirty="0"/>
           </a:p>
@@ -2266,21 +2427,21 @@
       </p:sp>
       <p:pic>
         <p:nvPicPr>
-          <p:cNvPr id="13" name="Image 1" descr="/sessions/cool-elegant-cori/stephen_photo.jpeg"/>
+          <p:cNvPr id="13" name="Image 1" descr="/sessions/cool-elegant-cori/rodney_photo.png">    </p:cNvPr>
           <p:cNvPicPr>
             <a:picLocks noChangeAspect="1"/>
           </p:cNvPicPr>
           <p:nvPr/>
         </p:nvPicPr>
         <p:blipFill>
-          <a:blip r:embed="rId4"/>
+          <a:blip r:embed="rId2"/>
           <a:stretch>
             <a:fillRect/>
           </a:stretch>
         </p:blipFill>
         <p:spPr>
           <a:xfrm>
-            <a:off x="759406" y="1645920"/>
+            <a:off x="731520" y="3017520"/>
             <a:ext cx="1005840" cy="1005840"/>
           </a:xfrm>
           <a:prstGeom prst="ellipse">
@@ -2309,7 +2470,7 @@
           <a:bodyPr wrap="square" lIns="0" tIns="0" rIns="0" bIns="0" rtlCol="0" anchor="ctr"/>
           <a:lstStyle/>
           <a:p>
-            <a:pPr marL="0" indent="0">
+            <a:pPr indent="0" marL="0">
               <a:buNone/>
             </a:pPr>
             <a:r>
@@ -2348,7 +2509,7 @@
           <a:bodyPr wrap="square" lIns="0" tIns="0" rIns="0" bIns="0" rtlCol="0" anchor="ctr"/>
           <a:lstStyle/>
           <a:p>
-            <a:pPr marL="0" indent="0">
+            <a:pPr indent="0" marL="0">
               <a:lnSpc>
                 <a:spcPct val="140000"/>
               </a:lnSpc>
@@ -2385,7 +2546,6 @@
         <a:solidFill>
           <a:srgbClr val="FAF6F1"/>
         </a:solidFill>
-        <a:effectLst/>
       </p:bgPr>
     </p:bg>
     <p:spTree>
@@ -2421,13 +2581,6 @@
           </a:solidFill>
           <a:ln/>
         </p:spPr>
-        <p:txBody>
-          <a:bodyPr/>
-          <a:lstStyle/>
-          <a:p>
-            <a:endParaRPr lang="en-AE"/>
-          </a:p>
-        </p:txBody>
       </p:sp>
       <p:sp>
         <p:nvSpPr>
@@ -2450,11 +2603,11 @@
           <a:bodyPr wrap="square" rtlCol="0" anchor="ctr"/>
           <a:lstStyle/>
           <a:p>
-            <a:pPr marL="0" indent="0" algn="ctr">
-              <a:buNone/>
-            </a:pPr>
-            <a:r>
-              <a:rPr lang="en-US" sz="800" b="1" kern="0" spc="300" dirty="0">
+            <a:pPr algn="ctr" indent="0" marL="0">
+              <a:buNone/>
+            </a:pPr>
+            <a:r>
+              <a:rPr lang="en-US" sz="800" b="1" spc="300" kern="0" dirty="0">
                 <a:solidFill>
                   <a:srgbClr val="F5EDE0"/>
                 </a:solidFill>
@@ -2489,11 +2642,11 @@
           <a:bodyPr wrap="square" rtlCol="0" anchor="ctr"/>
           <a:lstStyle/>
           <a:p>
-            <a:pPr marL="0" indent="0">
-              <a:buNone/>
-            </a:pPr>
-            <a:r>
-              <a:rPr lang="en-US" sz="900" b="1" kern="0" spc="300" dirty="0">
+            <a:pPr indent="0" marL="0">
+              <a:buNone/>
+            </a:pPr>
+            <a:r>
+              <a:rPr lang="en-US" sz="900" b="1" spc="300" kern="0" dirty="0">
                 <a:solidFill>
                   <a:srgbClr val="006B5E"/>
                 </a:solidFill>
@@ -2529,13 +2682,6 @@
             <a:prstDash val="solid"/>
           </a:ln>
         </p:spPr>
-        <p:txBody>
-          <a:bodyPr/>
-          <a:lstStyle/>
-          <a:p>
-            <a:endParaRPr lang="en-AE"/>
-          </a:p>
-        </p:txBody>
       </p:sp>
       <p:sp>
         <p:nvSpPr>
@@ -2558,7 +2704,7 @@
           <a:bodyPr wrap="square" lIns="0" tIns="0" rIns="0" bIns="0" rtlCol="0" anchor="ctr"/>
           <a:lstStyle/>
           <a:p>
-            <a:pPr marL="0" indent="0">
+            <a:pPr indent="0" marL="0">
               <a:buNone/>
             </a:pPr>
             <a:r>
@@ -2595,13 +2741,6 @@
           </a:solidFill>
           <a:ln/>
         </p:spPr>
-        <p:txBody>
-          <a:bodyPr/>
-          <a:lstStyle/>
-          <a:p>
-            <a:endParaRPr lang="en-AE"/>
-          </a:p>
-        </p:txBody>
       </p:sp>
       <p:sp>
         <p:nvSpPr>
@@ -2624,7 +2763,7 @@
           <a:bodyPr wrap="square" rtlCol="0" anchor="ctr"/>
           <a:lstStyle/>
           <a:p>
-            <a:pPr marL="0" indent="0">
+            <a:pPr indent="0" marL="0">
               <a:buNone/>
             </a:pPr>
             <a:r>
@@ -2663,7 +2802,7 @@
           <a:bodyPr wrap="square" rtlCol="0" anchor="ctr"/>
           <a:lstStyle/>
           <a:p>
-            <a:pPr marL="0" indent="0" algn="r">
+            <a:pPr algn="r" indent="0" marL="0">
               <a:buNone/>
             </a:pPr>
             <a:r>
@@ -2702,7 +2841,7 @@
           <a:bodyPr wrap="square" rtlCol="0" anchor="ctr"/>
           <a:lstStyle/>
           <a:p>
-            <a:pPr marL="0" indent="0">
+            <a:pPr indent="0" marL="0">
               <a:lnSpc>
                 <a:spcPct val="140000"/>
               </a:lnSpc>
@@ -2742,20 +2881,13 @@
           </a:solidFill>
           <a:ln/>
           <a:effectLst>
-            <a:outerShdw blurRad="76200" dist="25400" dir="8100000" algn="bl" rotWithShape="0">
+            <a:outerShdw sx="100000" sy="100000" kx="0" ky="0" algn="bl" rotWithShape="0" blurRad="76200" dist="25400" dir="8100000">
               <a:srgbClr val="000000">
                 <a:alpha val="10000"/>
               </a:srgbClr>
             </a:outerShdw>
           </a:effectLst>
         </p:spPr>
-        <p:txBody>
-          <a:bodyPr/>
-          <a:lstStyle/>
-          <a:p>
-            <a:endParaRPr lang="en-AE"/>
-          </a:p>
-        </p:txBody>
       </p:sp>
       <p:sp>
         <p:nvSpPr>
@@ -2776,13 +2908,6 @@
           </a:solidFill>
           <a:ln/>
         </p:spPr>
-        <p:txBody>
-          <a:bodyPr/>
-          <a:lstStyle/>
-          <a:p>
-            <a:endParaRPr lang="en-AE"/>
-          </a:p>
-        </p:txBody>
       </p:sp>
       <p:sp>
         <p:nvSpPr>
@@ -2805,7 +2930,7 @@
           <a:bodyPr wrap="square" lIns="0" tIns="0" rIns="0" bIns="0" rtlCol="0" anchor="ctr"/>
           <a:lstStyle/>
           <a:p>
-            <a:pPr marL="0" indent="0">
+            <a:pPr indent="0" marL="0">
               <a:buNone/>
             </a:pPr>
             <a:r>
@@ -2844,7 +2969,7 @@
           <a:bodyPr wrap="square" lIns="0" tIns="0" rIns="0" bIns="0" rtlCol="0" anchor="ctr"/>
           <a:lstStyle/>
           <a:p>
-            <a:pPr marL="0" indent="0">
+            <a:pPr indent="0" marL="0">
               <a:lnSpc>
                 <a:spcPct val="130000"/>
               </a:lnSpc>
@@ -2884,20 +3009,13 @@
           </a:solidFill>
           <a:ln/>
           <a:effectLst>
-            <a:outerShdw blurRad="76200" dist="25400" dir="8100000" algn="bl" rotWithShape="0">
+            <a:outerShdw sx="100000" sy="100000" kx="0" ky="0" algn="bl" rotWithShape="0" blurRad="76200" dist="25400" dir="8100000">
               <a:srgbClr val="000000">
                 <a:alpha val="10000"/>
               </a:srgbClr>
             </a:outerShdw>
           </a:effectLst>
         </p:spPr>
-        <p:txBody>
-          <a:bodyPr/>
-          <a:lstStyle/>
-          <a:p>
-            <a:endParaRPr lang="en-AE"/>
-          </a:p>
-        </p:txBody>
       </p:sp>
       <p:sp>
         <p:nvSpPr>
@@ -2918,13 +3036,6 @@
           </a:solidFill>
           <a:ln/>
         </p:spPr>
-        <p:txBody>
-          <a:bodyPr/>
-          <a:lstStyle/>
-          <a:p>
-            <a:endParaRPr lang="en-AE"/>
-          </a:p>
-        </p:txBody>
       </p:sp>
       <p:sp>
         <p:nvSpPr>
@@ -2947,7 +3058,7 @@
           <a:bodyPr wrap="square" lIns="0" tIns="0" rIns="0" bIns="0" rtlCol="0" anchor="ctr"/>
           <a:lstStyle/>
           <a:p>
-            <a:pPr marL="0" indent="0">
+            <a:pPr indent="0" marL="0">
               <a:buNone/>
             </a:pPr>
             <a:r>
@@ -2986,7 +3097,7 @@
           <a:bodyPr wrap="square" lIns="0" tIns="0" rIns="0" bIns="0" rtlCol="0" anchor="ctr"/>
           <a:lstStyle/>
           <a:p>
-            <a:pPr marL="0" indent="0">
+            <a:pPr indent="0" marL="0">
               <a:lnSpc>
                 <a:spcPct val="130000"/>
               </a:lnSpc>
@@ -3026,20 +3137,13 @@
           </a:solidFill>
           <a:ln/>
           <a:effectLst>
-            <a:outerShdw blurRad="76200" dist="25400" dir="8100000" algn="bl" rotWithShape="0">
+            <a:outerShdw sx="100000" sy="100000" kx="0" ky="0" algn="bl" rotWithShape="0" blurRad="76200" dist="25400" dir="8100000">
               <a:srgbClr val="000000">
                 <a:alpha val="10000"/>
               </a:srgbClr>
             </a:outerShdw>
           </a:effectLst>
         </p:spPr>
-        <p:txBody>
-          <a:bodyPr/>
-          <a:lstStyle/>
-          <a:p>
-            <a:endParaRPr lang="en-AE"/>
-          </a:p>
-        </p:txBody>
       </p:sp>
       <p:sp>
         <p:nvSpPr>
@@ -3060,13 +3164,6 @@
           </a:solidFill>
           <a:ln/>
         </p:spPr>
-        <p:txBody>
-          <a:bodyPr/>
-          <a:lstStyle/>
-          <a:p>
-            <a:endParaRPr lang="en-AE"/>
-          </a:p>
-        </p:txBody>
       </p:sp>
       <p:sp>
         <p:nvSpPr>
@@ -3089,7 +3186,7 @@
           <a:bodyPr wrap="square" lIns="0" tIns="0" rIns="0" bIns="0" rtlCol="0" anchor="ctr"/>
           <a:lstStyle/>
           <a:p>
-            <a:pPr marL="0" indent="0">
+            <a:pPr indent="0" marL="0">
               <a:buNone/>
             </a:pPr>
             <a:r>
@@ -3128,7 +3225,7 @@
           <a:bodyPr wrap="square" lIns="0" tIns="0" rIns="0" bIns="0" rtlCol="0" anchor="ctr"/>
           <a:lstStyle/>
           <a:p>
-            <a:pPr marL="0" indent="0">
+            <a:pPr indent="0" marL="0">
               <a:lnSpc>
                 <a:spcPct val="130000"/>
               </a:lnSpc>
@@ -3168,20 +3265,13 @@
           </a:solidFill>
           <a:ln/>
           <a:effectLst>
-            <a:outerShdw blurRad="76200" dist="25400" dir="8100000" algn="bl" rotWithShape="0">
+            <a:outerShdw sx="100000" sy="100000" kx="0" ky="0" algn="bl" rotWithShape="0" blurRad="76200" dist="25400" dir="8100000">
               <a:srgbClr val="000000">
                 <a:alpha val="10000"/>
               </a:srgbClr>
             </a:outerShdw>
           </a:effectLst>
         </p:spPr>
-        <p:txBody>
-          <a:bodyPr/>
-          <a:lstStyle/>
-          <a:p>
-            <a:endParaRPr lang="en-AE"/>
-          </a:p>
-        </p:txBody>
       </p:sp>
       <p:sp>
         <p:nvSpPr>
@@ -3202,13 +3292,6 @@
           </a:solidFill>
           <a:ln/>
         </p:spPr>
-        <p:txBody>
-          <a:bodyPr/>
-          <a:lstStyle/>
-          <a:p>
-            <a:endParaRPr lang="en-AE"/>
-          </a:p>
-        </p:txBody>
       </p:sp>
       <p:sp>
         <p:nvSpPr>
@@ -3231,7 +3314,7 @@
           <a:bodyPr wrap="square" lIns="0" tIns="0" rIns="0" bIns="0" rtlCol="0" anchor="ctr"/>
           <a:lstStyle/>
           <a:p>
-            <a:pPr marL="0" indent="0">
+            <a:pPr indent="0" marL="0">
               <a:buNone/>
             </a:pPr>
             <a:r>
@@ -3270,7 +3353,7 @@
           <a:bodyPr wrap="square" lIns="0" tIns="0" rIns="0" bIns="0" rtlCol="0" anchor="ctr"/>
           <a:lstStyle/>
           <a:p>
-            <a:pPr marL="0" indent="0">
+            <a:pPr indent="0" marL="0">
               <a:lnSpc>
                 <a:spcPct val="130000"/>
               </a:lnSpc>
@@ -3307,7 +3390,6 @@
         <a:solidFill>
           <a:srgbClr val="FAF6F1"/>
         </a:solidFill>
-        <a:effectLst/>
       </p:bgPr>
     </p:bg>
     <p:spTree>
@@ -3343,13 +3425,6 @@
           </a:solidFill>
           <a:ln/>
         </p:spPr>
-        <p:txBody>
-          <a:bodyPr/>
-          <a:lstStyle/>
-          <a:p>
-            <a:endParaRPr lang="en-AE"/>
-          </a:p>
-        </p:txBody>
       </p:sp>
       <p:sp>
         <p:nvSpPr>
@@ -3372,11 +3447,11 @@
           <a:bodyPr wrap="square" rtlCol="0" anchor="ctr"/>
           <a:lstStyle/>
           <a:p>
-            <a:pPr marL="0" indent="0" algn="ctr">
-              <a:buNone/>
-            </a:pPr>
-            <a:r>
-              <a:rPr lang="en-US" sz="800" b="1" kern="0" spc="300" dirty="0">
+            <a:pPr algn="ctr" indent="0" marL="0">
+              <a:buNone/>
+            </a:pPr>
+            <a:r>
+              <a:rPr lang="en-US" sz="800" b="1" spc="300" kern="0" dirty="0">
                 <a:solidFill>
                   <a:srgbClr val="F5EDE0"/>
                 </a:solidFill>
@@ -3411,11 +3486,11 @@
           <a:bodyPr wrap="square" rtlCol="0" anchor="ctr"/>
           <a:lstStyle/>
           <a:p>
-            <a:pPr marL="0" indent="0">
-              <a:buNone/>
-            </a:pPr>
-            <a:r>
-              <a:rPr lang="en-US" sz="900" b="1" kern="0" spc="300" dirty="0">
+            <a:pPr indent="0" marL="0">
+              <a:buNone/>
+            </a:pPr>
+            <a:r>
+              <a:rPr lang="en-US" sz="900" b="1" spc="300" kern="0" dirty="0">
                 <a:solidFill>
                   <a:srgbClr val="006B5E"/>
                 </a:solidFill>
@@ -3451,13 +3526,6 @@
             <a:prstDash val="solid"/>
           </a:ln>
         </p:spPr>
-        <p:txBody>
-          <a:bodyPr/>
-          <a:lstStyle/>
-          <a:p>
-            <a:endParaRPr lang="en-AE"/>
-          </a:p>
-        </p:txBody>
       </p:sp>
       <p:sp>
         <p:nvSpPr>
@@ -3480,7 +3548,7 @@
           <a:bodyPr wrap="square" lIns="0" tIns="0" rIns="0" bIns="0" rtlCol="0" anchor="ctr"/>
           <a:lstStyle/>
           <a:p>
-            <a:pPr marL="0" indent="0">
+            <a:pPr indent="0" marL="0">
               <a:buNone/>
             </a:pPr>
             <a:r>
@@ -3517,13 +3585,6 @@
           </a:solidFill>
           <a:ln/>
         </p:spPr>
-        <p:txBody>
-          <a:bodyPr/>
-          <a:lstStyle/>
-          <a:p>
-            <a:endParaRPr lang="en-AE"/>
-          </a:p>
-        </p:txBody>
       </p:sp>
       <p:sp>
         <p:nvSpPr>
@@ -3546,7 +3607,7 @@
           <a:bodyPr wrap="square" rtlCol="0" anchor="ctr"/>
           <a:lstStyle/>
           <a:p>
-            <a:pPr marL="0" indent="0">
+            <a:pPr indent="0" marL="0">
               <a:buNone/>
             </a:pPr>
             <a:r>
@@ -3585,7 +3646,7 @@
           <a:bodyPr wrap="square" rtlCol="0" anchor="ctr"/>
           <a:lstStyle/>
           <a:p>
-            <a:pPr marL="0" indent="0" algn="r">
+            <a:pPr algn="r" indent="0" marL="0">
               <a:buNone/>
             </a:pPr>
             <a:r>
@@ -3624,7 +3685,7 @@
           <a:bodyPr wrap="square" rtlCol="0" anchor="ctr"/>
           <a:lstStyle/>
           <a:p>
-            <a:pPr marL="0" indent="0">
+            <a:pPr indent="0" marL="0">
               <a:lnSpc>
                 <a:spcPct val="140000"/>
               </a:lnSpc>
@@ -3664,20 +3725,13 @@
           </a:solidFill>
           <a:ln/>
           <a:effectLst>
-            <a:outerShdw blurRad="76200" dist="25400" dir="8100000" algn="bl" rotWithShape="0">
+            <a:outerShdw sx="100000" sy="100000" kx="0" ky="0" algn="bl" rotWithShape="0" blurRad="76200" dist="25400" dir="8100000">
               <a:srgbClr val="000000">
                 <a:alpha val="10000"/>
               </a:srgbClr>
             </a:outerShdw>
           </a:effectLst>
         </p:spPr>
-        <p:txBody>
-          <a:bodyPr/>
-          <a:lstStyle/>
-          <a:p>
-            <a:endParaRPr lang="en-AE"/>
-          </a:p>
-        </p:txBody>
       </p:sp>
       <p:sp>
         <p:nvSpPr>
@@ -3698,13 +3752,6 @@
           </a:solidFill>
           <a:ln/>
         </p:spPr>
-        <p:txBody>
-          <a:bodyPr/>
-          <a:lstStyle/>
-          <a:p>
-            <a:endParaRPr lang="en-AE"/>
-          </a:p>
-        </p:txBody>
       </p:sp>
       <p:sp>
         <p:nvSpPr>
@@ -3727,7 +3774,7 @@
           <a:bodyPr wrap="square" lIns="0" tIns="0" rIns="0" bIns="0" rtlCol="0" anchor="ctr"/>
           <a:lstStyle/>
           <a:p>
-            <a:pPr marL="0" indent="0">
+            <a:pPr indent="0" marL="0">
               <a:buNone/>
             </a:pPr>
             <a:r>
@@ -3766,7 +3813,7 @@
           <a:bodyPr wrap="square" lIns="0" tIns="0" rIns="0" bIns="0" rtlCol="0" anchor="ctr"/>
           <a:lstStyle/>
           <a:p>
-            <a:pPr marL="0" indent="0">
+            <a:pPr indent="0" marL="0">
               <a:buNone/>
             </a:pPr>
             <a:r>
@@ -3783,7 +3830,7 @@
             <a:endParaRPr lang="en-US" sz="1100" dirty="0"/>
           </a:p>
           <a:p>
-            <a:pPr marL="0" indent="0">
+            <a:pPr indent="0" marL="0">
               <a:buNone/>
             </a:pPr>
             <a:r>
@@ -3822,7 +3869,7 @@
           <a:bodyPr wrap="square" lIns="0" tIns="0" rIns="0" bIns="0" rtlCol="0" anchor="ctr"/>
           <a:lstStyle/>
           <a:p>
-            <a:pPr marL="0" indent="0">
+            <a:pPr indent="0" marL="0">
               <a:lnSpc>
                 <a:spcPct val="130000"/>
               </a:lnSpc>
@@ -3862,20 +3909,13 @@
           </a:solidFill>
           <a:ln/>
           <a:effectLst>
-            <a:outerShdw blurRad="76200" dist="25400" dir="8100000" algn="bl" rotWithShape="0">
+            <a:outerShdw sx="100000" sy="100000" kx="0" ky="0" algn="bl" rotWithShape="0" blurRad="76200" dist="25400" dir="8100000">
               <a:srgbClr val="000000">
                 <a:alpha val="10000"/>
               </a:srgbClr>
             </a:outerShdw>
           </a:effectLst>
         </p:spPr>
-        <p:txBody>
-          <a:bodyPr/>
-          <a:lstStyle/>
-          <a:p>
-            <a:endParaRPr lang="en-AE"/>
-          </a:p>
-        </p:txBody>
       </p:sp>
       <p:sp>
         <p:nvSpPr>
@@ -3896,13 +3936,6 @@
           </a:solidFill>
           <a:ln/>
         </p:spPr>
-        <p:txBody>
-          <a:bodyPr/>
-          <a:lstStyle/>
-          <a:p>
-            <a:endParaRPr lang="en-AE"/>
-          </a:p>
-        </p:txBody>
       </p:sp>
       <p:sp>
         <p:nvSpPr>
@@ -3925,7 +3958,7 @@
           <a:bodyPr wrap="square" lIns="0" tIns="0" rIns="0" bIns="0" rtlCol="0" anchor="ctr"/>
           <a:lstStyle/>
           <a:p>
-            <a:pPr marL="0" indent="0">
+            <a:pPr indent="0" marL="0">
               <a:buNone/>
             </a:pPr>
             <a:r>
@@ -3964,7 +3997,7 @@
           <a:bodyPr wrap="square" lIns="0" tIns="0" rIns="0" bIns="0" rtlCol="0" anchor="ctr"/>
           <a:lstStyle/>
           <a:p>
-            <a:pPr marL="0" indent="0">
+            <a:pPr indent="0" marL="0">
               <a:buNone/>
             </a:pPr>
             <a:r>
@@ -3981,7 +4014,7 @@
             <a:endParaRPr lang="en-US" sz="1100" dirty="0"/>
           </a:p>
           <a:p>
-            <a:pPr marL="0" indent="0">
+            <a:pPr indent="0" marL="0">
               <a:buNone/>
             </a:pPr>
             <a:r>
@@ -4020,7 +4053,7 @@
           <a:bodyPr wrap="square" lIns="0" tIns="0" rIns="0" bIns="0" rtlCol="0" anchor="ctr"/>
           <a:lstStyle/>
           <a:p>
-            <a:pPr marL="0" indent="0">
+            <a:pPr indent="0" marL="0">
               <a:lnSpc>
                 <a:spcPct val="130000"/>
               </a:lnSpc>
@@ -4060,20 +4093,13 @@
           </a:solidFill>
           <a:ln/>
           <a:effectLst>
-            <a:outerShdw blurRad="76200" dist="25400" dir="8100000" algn="bl" rotWithShape="0">
+            <a:outerShdw sx="100000" sy="100000" kx="0" ky="0" algn="bl" rotWithShape="0" blurRad="76200" dist="25400" dir="8100000">
               <a:srgbClr val="000000">
                 <a:alpha val="10000"/>
               </a:srgbClr>
             </a:outerShdw>
           </a:effectLst>
         </p:spPr>
-        <p:txBody>
-          <a:bodyPr/>
-          <a:lstStyle/>
-          <a:p>
-            <a:endParaRPr lang="en-AE"/>
-          </a:p>
-        </p:txBody>
       </p:sp>
       <p:sp>
         <p:nvSpPr>
@@ -4094,13 +4120,6 @@
           </a:solidFill>
           <a:ln/>
         </p:spPr>
-        <p:txBody>
-          <a:bodyPr/>
-          <a:lstStyle/>
-          <a:p>
-            <a:endParaRPr lang="en-AE"/>
-          </a:p>
-        </p:txBody>
       </p:sp>
       <p:sp>
         <p:nvSpPr>
@@ -4123,7 +4142,7 @@
           <a:bodyPr wrap="square" lIns="0" tIns="0" rIns="0" bIns="0" rtlCol="0" anchor="ctr"/>
           <a:lstStyle/>
           <a:p>
-            <a:pPr marL="0" indent="0">
+            <a:pPr indent="0" marL="0">
               <a:buNone/>
             </a:pPr>
             <a:r>
@@ -4162,7 +4181,7 @@
           <a:bodyPr wrap="square" lIns="0" tIns="0" rIns="0" bIns="0" rtlCol="0" anchor="ctr"/>
           <a:lstStyle/>
           <a:p>
-            <a:pPr marL="0" indent="0">
+            <a:pPr indent="0" marL="0">
               <a:buNone/>
             </a:pPr>
             <a:r>
@@ -4179,7 +4198,7 @@
             <a:endParaRPr lang="en-US" sz="1100" dirty="0"/>
           </a:p>
           <a:p>
-            <a:pPr marL="0" indent="0">
+            <a:pPr indent="0" marL="0">
               <a:buNone/>
             </a:pPr>
             <a:r>
@@ -4218,7 +4237,7 @@
           <a:bodyPr wrap="square" lIns="0" tIns="0" rIns="0" bIns="0" rtlCol="0" anchor="ctr"/>
           <a:lstStyle/>
           <a:p>
-            <a:pPr marL="0" indent="0">
+            <a:pPr indent="0" marL="0">
               <a:lnSpc>
                 <a:spcPct val="130000"/>
               </a:lnSpc>
@@ -4258,20 +4277,13 @@
           </a:solidFill>
           <a:ln/>
           <a:effectLst>
-            <a:outerShdw blurRad="76200" dist="25400" dir="8100000" algn="bl" rotWithShape="0">
+            <a:outerShdw sx="100000" sy="100000" kx="0" ky="0" algn="bl" rotWithShape="0" blurRad="76200" dist="25400" dir="8100000">
               <a:srgbClr val="000000">
                 <a:alpha val="10000"/>
               </a:srgbClr>
             </a:outerShdw>
           </a:effectLst>
         </p:spPr>
-        <p:txBody>
-          <a:bodyPr/>
-          <a:lstStyle/>
-          <a:p>
-            <a:endParaRPr lang="en-AE"/>
-          </a:p>
-        </p:txBody>
       </p:sp>
       <p:sp>
         <p:nvSpPr>
@@ -4292,13 +4304,6 @@
           </a:solidFill>
           <a:ln/>
         </p:spPr>
-        <p:txBody>
-          <a:bodyPr/>
-          <a:lstStyle/>
-          <a:p>
-            <a:endParaRPr lang="en-AE"/>
-          </a:p>
-        </p:txBody>
       </p:sp>
       <p:sp>
         <p:nvSpPr>
@@ -4321,7 +4326,7 @@
           <a:bodyPr wrap="square" lIns="0" tIns="0" rIns="0" bIns="0" rtlCol="0" anchor="ctr"/>
           <a:lstStyle/>
           <a:p>
-            <a:pPr marL="0" indent="0">
+            <a:pPr indent="0" marL="0">
               <a:buNone/>
             </a:pPr>
             <a:r>
@@ -4360,7 +4365,7 @@
           <a:bodyPr wrap="square" lIns="0" tIns="0" rIns="0" bIns="0" rtlCol="0" anchor="ctr"/>
           <a:lstStyle/>
           <a:p>
-            <a:pPr marL="0" indent="0">
+            <a:pPr indent="0" marL="0">
               <a:buNone/>
             </a:pPr>
             <a:r>
@@ -4377,7 +4382,7 @@
             <a:endParaRPr lang="en-US" sz="1100" dirty="0"/>
           </a:p>
           <a:p>
-            <a:pPr marL="0" indent="0">
+            <a:pPr indent="0" marL="0">
               <a:buNone/>
             </a:pPr>
             <a:r>
@@ -4416,7 +4421,7 @@
           <a:bodyPr wrap="square" lIns="0" tIns="0" rIns="0" bIns="0" rtlCol="0" anchor="ctr"/>
           <a:lstStyle/>
           <a:p>
-            <a:pPr marL="0" indent="0">
+            <a:pPr indent="0" marL="0">
               <a:lnSpc>
                 <a:spcPct val="130000"/>
               </a:lnSpc>
@@ -4456,20 +4461,13 @@
           </a:solidFill>
           <a:ln/>
           <a:effectLst>
-            <a:outerShdw blurRad="76200" dist="25400" dir="8100000" algn="bl" rotWithShape="0">
+            <a:outerShdw sx="100000" sy="100000" kx="0" ky="0" algn="bl" rotWithShape="0" blurRad="76200" dist="25400" dir="8100000">
               <a:srgbClr val="000000">
                 <a:alpha val="10000"/>
               </a:srgbClr>
             </a:outerShdw>
           </a:effectLst>
         </p:spPr>
-        <p:txBody>
-          <a:bodyPr/>
-          <a:lstStyle/>
-          <a:p>
-            <a:endParaRPr lang="en-AE"/>
-          </a:p>
-        </p:txBody>
       </p:sp>
       <p:sp>
         <p:nvSpPr>
@@ -4490,13 +4488,6 @@
           </a:solidFill>
           <a:ln/>
         </p:spPr>
-        <p:txBody>
-          <a:bodyPr/>
-          <a:lstStyle/>
-          <a:p>
-            <a:endParaRPr lang="en-AE"/>
-          </a:p>
-        </p:txBody>
       </p:sp>
       <p:sp>
         <p:nvSpPr>
@@ -4519,7 +4510,7 @@
           <a:bodyPr wrap="square" lIns="0" tIns="0" rIns="0" bIns="0" rtlCol="0" anchor="ctr"/>
           <a:lstStyle/>
           <a:p>
-            <a:pPr marL="0" indent="0">
+            <a:pPr indent="0" marL="0">
               <a:buNone/>
             </a:pPr>
             <a:r>
@@ -4558,7 +4549,7 @@
           <a:bodyPr wrap="square" lIns="0" tIns="0" rIns="0" bIns="0" rtlCol="0" anchor="ctr"/>
           <a:lstStyle/>
           <a:p>
-            <a:pPr marL="0" indent="0">
+            <a:pPr indent="0" marL="0">
               <a:buNone/>
             </a:pPr>
             <a:r>
@@ -4575,7 +4566,7 @@
             <a:endParaRPr lang="en-US" sz="1100" dirty="0"/>
           </a:p>
           <a:p>
-            <a:pPr marL="0" indent="0">
+            <a:pPr indent="0" marL="0">
               <a:buNone/>
             </a:pPr>
             <a:r>
@@ -4614,7 +4605,7 @@
           <a:bodyPr wrap="square" lIns="0" tIns="0" rIns="0" bIns="0" rtlCol="0" anchor="ctr"/>
           <a:lstStyle/>
           <a:p>
-            <a:pPr marL="0" indent="0">
+            <a:pPr indent="0" marL="0">
               <a:lnSpc>
                 <a:spcPct val="130000"/>
               </a:lnSpc>
@@ -4651,7 +4642,6 @@
         <a:solidFill>
           <a:srgbClr val="FAF6F1"/>
         </a:solidFill>
-        <a:effectLst/>
       </p:bgPr>
     </p:bg>
     <p:spTree>
@@ -4687,13 +4677,6 @@
           </a:solidFill>
           <a:ln/>
         </p:spPr>
-        <p:txBody>
-          <a:bodyPr/>
-          <a:lstStyle/>
-          <a:p>
-            <a:endParaRPr lang="en-AE"/>
-          </a:p>
-        </p:txBody>
       </p:sp>
       <p:sp>
         <p:nvSpPr>
@@ -4716,11 +4699,11 @@
           <a:bodyPr wrap="square" rtlCol="0" anchor="ctr"/>
           <a:lstStyle/>
           <a:p>
-            <a:pPr marL="0" indent="0" algn="ctr">
-              <a:buNone/>
-            </a:pPr>
-            <a:r>
-              <a:rPr lang="en-US" sz="800" b="1" kern="0" spc="300" dirty="0">
+            <a:pPr algn="ctr" indent="0" marL="0">
+              <a:buNone/>
+            </a:pPr>
+            <a:r>
+              <a:rPr lang="en-US" sz="800" b="1" spc="300" kern="0" dirty="0">
                 <a:solidFill>
                   <a:srgbClr val="F5EDE0"/>
                 </a:solidFill>
@@ -4755,11 +4738,11 @@
           <a:bodyPr wrap="square" rtlCol="0" anchor="ctr"/>
           <a:lstStyle/>
           <a:p>
-            <a:pPr marL="0" indent="0">
-              <a:buNone/>
-            </a:pPr>
-            <a:r>
-              <a:rPr lang="en-US" sz="900" b="1" kern="0" spc="300" dirty="0">
+            <a:pPr indent="0" marL="0">
+              <a:buNone/>
+            </a:pPr>
+            <a:r>
+              <a:rPr lang="en-US" sz="900" b="1" spc="300" kern="0" dirty="0">
                 <a:solidFill>
                   <a:srgbClr val="006B5E"/>
                 </a:solidFill>
@@ -4795,13 +4778,6 @@
             <a:prstDash val="solid"/>
           </a:ln>
         </p:spPr>
-        <p:txBody>
-          <a:bodyPr/>
-          <a:lstStyle/>
-          <a:p>
-            <a:endParaRPr lang="en-AE"/>
-          </a:p>
-        </p:txBody>
       </p:sp>
       <p:sp>
         <p:nvSpPr>
@@ -4824,7 +4800,7 @@
           <a:bodyPr wrap="square" lIns="0" tIns="0" rIns="0" bIns="0" rtlCol="0" anchor="ctr"/>
           <a:lstStyle/>
           <a:p>
-            <a:pPr marL="0" indent="0">
+            <a:pPr indent="0" marL="0">
               <a:buNone/>
             </a:pPr>
             <a:r>
@@ -4861,13 +4837,6 @@
           </a:solidFill>
           <a:ln/>
         </p:spPr>
-        <p:txBody>
-          <a:bodyPr/>
-          <a:lstStyle/>
-          <a:p>
-            <a:endParaRPr lang="en-AE"/>
-          </a:p>
-        </p:txBody>
       </p:sp>
       <p:sp>
         <p:nvSpPr>
@@ -4890,7 +4859,7 @@
           <a:bodyPr wrap="square" rtlCol="0" anchor="ctr"/>
           <a:lstStyle/>
           <a:p>
-            <a:pPr marL="0" indent="0">
+            <a:pPr indent="0" marL="0">
               <a:buNone/>
             </a:pPr>
             <a:r>
@@ -4929,7 +4898,7 @@
           <a:bodyPr wrap="square" rtlCol="0" anchor="ctr"/>
           <a:lstStyle/>
           <a:p>
-            <a:pPr marL="0" indent="0" algn="r">
+            <a:pPr algn="r" indent="0" marL="0">
               <a:buNone/>
             </a:pPr>
             <a:r>
@@ -4968,7 +4937,7 @@
           <a:bodyPr wrap="square" rtlCol="0" anchor="ctr"/>
           <a:lstStyle/>
           <a:p>
-            <a:pPr marL="0" indent="0">
+            <a:pPr indent="0" marL="0">
               <a:lnSpc>
                 <a:spcPct val="140000"/>
               </a:lnSpc>
@@ -5008,20 +4977,13 @@
           </a:solidFill>
           <a:ln/>
           <a:effectLst>
-            <a:outerShdw blurRad="76200" dist="25400" dir="8100000" algn="bl" rotWithShape="0">
+            <a:outerShdw sx="100000" sy="100000" kx="0" ky="0" algn="bl" rotWithShape="0" blurRad="76200" dist="25400" dir="8100000">
               <a:srgbClr val="000000">
                 <a:alpha val="10000"/>
               </a:srgbClr>
             </a:outerShdw>
           </a:effectLst>
         </p:spPr>
-        <p:txBody>
-          <a:bodyPr/>
-          <a:lstStyle/>
-          <a:p>
-            <a:endParaRPr lang="en-AE"/>
-          </a:p>
-        </p:txBody>
       </p:sp>
       <p:sp>
         <p:nvSpPr>
@@ -5042,13 +5004,6 @@
           </a:solidFill>
           <a:ln/>
         </p:spPr>
-        <p:txBody>
-          <a:bodyPr/>
-          <a:lstStyle/>
-          <a:p>
-            <a:endParaRPr lang="en-AE"/>
-          </a:p>
-        </p:txBody>
       </p:sp>
       <p:sp>
         <p:nvSpPr>
@@ -5071,7 +5026,7 @@
           <a:bodyPr wrap="square" lIns="0" tIns="0" rIns="0" bIns="0" rtlCol="0" anchor="ctr"/>
           <a:lstStyle/>
           <a:p>
-            <a:pPr marL="0" indent="0">
+            <a:pPr indent="0" marL="0">
               <a:buNone/>
             </a:pPr>
             <a:r>
@@ -5088,7 +5043,7 @@
             <a:endParaRPr lang="en-US" sz="1100" dirty="0"/>
           </a:p>
           <a:p>
-            <a:pPr marL="0" indent="0">
+            <a:pPr indent="0" marL="0">
               <a:buNone/>
             </a:pPr>
             <a:r>
@@ -5128,13 +5083,6 @@
             <a:prstDash val="solid"/>
           </a:ln>
         </p:spPr>
-        <p:txBody>
-          <a:bodyPr/>
-          <a:lstStyle/>
-          <a:p>
-            <a:endParaRPr lang="en-AE"/>
-          </a:p>
-        </p:txBody>
       </p:sp>
       <p:sp>
         <p:nvSpPr>
@@ -5157,7 +5105,7 @@
           <a:bodyPr wrap="square" lIns="0" tIns="0" rIns="0" bIns="0" rtlCol="0" anchor="ctr"/>
           <a:lstStyle/>
           <a:p>
-            <a:pPr marL="0" indent="0">
+            <a:pPr indent="0" marL="0">
               <a:lnSpc>
                 <a:spcPct val="150000"/>
               </a:lnSpc>
@@ -5177,7 +5125,7 @@
             <a:endParaRPr lang="en-US" sz="850" dirty="0"/>
           </a:p>
           <a:p>
-            <a:pPr marL="0" indent="0">
+            <a:pPr indent="0" marL="0">
               <a:lnSpc>
                 <a:spcPct val="150000"/>
               </a:lnSpc>
@@ -5197,7 +5145,7 @@
             <a:endParaRPr lang="en-US" sz="850" dirty="0"/>
           </a:p>
           <a:p>
-            <a:pPr marL="0" indent="0">
+            <a:pPr indent="0" marL="0">
               <a:lnSpc>
                 <a:spcPct val="150000"/>
               </a:lnSpc>
@@ -5217,7 +5165,7 @@
             <a:endParaRPr lang="en-US" sz="850" dirty="0"/>
           </a:p>
           <a:p>
-            <a:pPr marL="0" indent="0">
+            <a:pPr indent="0" marL="0">
               <a:lnSpc>
                 <a:spcPct val="150000"/>
               </a:lnSpc>
@@ -5237,7 +5185,7 @@
             <a:endParaRPr lang="en-US" sz="850" dirty="0"/>
           </a:p>
           <a:p>
-            <a:pPr marL="0" indent="0">
+            <a:pPr indent="0" marL="0">
               <a:lnSpc>
                 <a:spcPct val="150000"/>
               </a:lnSpc>
@@ -5277,20 +5225,13 @@
           </a:solidFill>
           <a:ln/>
           <a:effectLst>
-            <a:outerShdw blurRad="76200" dist="25400" dir="8100000" algn="bl" rotWithShape="0">
+            <a:outerShdw sx="100000" sy="100000" kx="0" ky="0" algn="bl" rotWithShape="0" blurRad="76200" dist="25400" dir="8100000">
               <a:srgbClr val="000000">
                 <a:alpha val="10000"/>
               </a:srgbClr>
             </a:outerShdw>
           </a:effectLst>
         </p:spPr>
-        <p:txBody>
-          <a:bodyPr/>
-          <a:lstStyle/>
-          <a:p>
-            <a:endParaRPr lang="en-AE"/>
-          </a:p>
-        </p:txBody>
       </p:sp>
       <p:sp>
         <p:nvSpPr>
@@ -5311,13 +5252,6 @@
           </a:solidFill>
           <a:ln/>
         </p:spPr>
-        <p:txBody>
-          <a:bodyPr/>
-          <a:lstStyle/>
-          <a:p>
-            <a:endParaRPr lang="en-AE"/>
-          </a:p>
-        </p:txBody>
       </p:sp>
       <p:sp>
         <p:nvSpPr>
@@ -5340,7 +5274,7 @@
           <a:bodyPr wrap="square" lIns="0" tIns="0" rIns="0" bIns="0" rtlCol="0" anchor="ctr"/>
           <a:lstStyle/>
           <a:p>
-            <a:pPr marL="0" indent="0">
+            <a:pPr indent="0" marL="0">
               <a:buNone/>
             </a:pPr>
             <a:r>
@@ -5357,7 +5291,7 @@
             <a:endParaRPr lang="en-US" sz="1100" dirty="0"/>
           </a:p>
           <a:p>
-            <a:pPr marL="0" indent="0">
+            <a:pPr indent="0" marL="0">
               <a:buNone/>
             </a:pPr>
             <a:r>
@@ -5397,13 +5331,6 @@
             <a:prstDash val="solid"/>
           </a:ln>
         </p:spPr>
-        <p:txBody>
-          <a:bodyPr/>
-          <a:lstStyle/>
-          <a:p>
-            <a:endParaRPr lang="en-AE"/>
-          </a:p>
-        </p:txBody>
       </p:sp>
       <p:sp>
         <p:nvSpPr>
@@ -5426,7 +5353,7 @@
           <a:bodyPr wrap="square" lIns="0" tIns="0" rIns="0" bIns="0" rtlCol="0" anchor="ctr"/>
           <a:lstStyle/>
           <a:p>
-            <a:pPr marL="0" indent="0">
+            <a:pPr indent="0" marL="0">
               <a:lnSpc>
                 <a:spcPct val="150000"/>
               </a:lnSpc>
@@ -5446,7 +5373,7 @@
             <a:endParaRPr lang="en-US" sz="850" dirty="0"/>
           </a:p>
           <a:p>
-            <a:pPr marL="0" indent="0">
+            <a:pPr indent="0" marL="0">
               <a:lnSpc>
                 <a:spcPct val="150000"/>
               </a:lnSpc>
@@ -5466,7 +5393,7 @@
             <a:endParaRPr lang="en-US" sz="850" dirty="0"/>
           </a:p>
           <a:p>
-            <a:pPr marL="0" indent="0">
+            <a:pPr indent="0" marL="0">
               <a:lnSpc>
                 <a:spcPct val="150000"/>
               </a:lnSpc>
@@ -5486,7 +5413,7 @@
             <a:endParaRPr lang="en-US" sz="850" dirty="0"/>
           </a:p>
           <a:p>
-            <a:pPr marL="0" indent="0">
+            <a:pPr indent="0" marL="0">
               <a:lnSpc>
                 <a:spcPct val="150000"/>
               </a:lnSpc>
@@ -5506,7 +5433,7 @@
             <a:endParaRPr lang="en-US" sz="850" dirty="0"/>
           </a:p>
           <a:p>
-            <a:pPr marL="0" indent="0">
+            <a:pPr indent="0" marL="0">
               <a:lnSpc>
                 <a:spcPct val="150000"/>
               </a:lnSpc>
@@ -5546,20 +5473,13 @@
           </a:solidFill>
           <a:ln/>
           <a:effectLst>
-            <a:outerShdw blurRad="76200" dist="25400" dir="8100000" algn="bl" rotWithShape="0">
+            <a:outerShdw sx="100000" sy="100000" kx="0" ky="0" algn="bl" rotWithShape="0" blurRad="76200" dist="25400" dir="8100000">
               <a:srgbClr val="000000">
                 <a:alpha val="10000"/>
               </a:srgbClr>
             </a:outerShdw>
           </a:effectLst>
         </p:spPr>
-        <p:txBody>
-          <a:bodyPr/>
-          <a:lstStyle/>
-          <a:p>
-            <a:endParaRPr lang="en-AE"/>
-          </a:p>
-        </p:txBody>
       </p:sp>
       <p:sp>
         <p:nvSpPr>
@@ -5580,13 +5500,6 @@
           </a:solidFill>
           <a:ln/>
         </p:spPr>
-        <p:txBody>
-          <a:bodyPr/>
-          <a:lstStyle/>
-          <a:p>
-            <a:endParaRPr lang="en-AE"/>
-          </a:p>
-        </p:txBody>
       </p:sp>
       <p:sp>
         <p:nvSpPr>
@@ -5609,7 +5522,7 @@
           <a:bodyPr wrap="square" lIns="0" tIns="0" rIns="0" bIns="0" rtlCol="0" anchor="ctr"/>
           <a:lstStyle/>
           <a:p>
-            <a:pPr marL="0" indent="0">
+            <a:pPr indent="0" marL="0">
               <a:buNone/>
             </a:pPr>
             <a:r>
@@ -5626,7 +5539,7 @@
             <a:endParaRPr lang="en-US" sz="1100" dirty="0"/>
           </a:p>
           <a:p>
-            <a:pPr marL="0" indent="0">
+            <a:pPr indent="0" marL="0">
               <a:buNone/>
             </a:pPr>
             <a:r>
@@ -5666,13 +5579,6 @@
             <a:prstDash val="solid"/>
           </a:ln>
         </p:spPr>
-        <p:txBody>
-          <a:bodyPr/>
-          <a:lstStyle/>
-          <a:p>
-            <a:endParaRPr lang="en-AE"/>
-          </a:p>
-        </p:txBody>
       </p:sp>
       <p:sp>
         <p:nvSpPr>
@@ -5695,7 +5601,7 @@
           <a:bodyPr wrap="square" lIns="0" tIns="0" rIns="0" bIns="0" rtlCol="0" anchor="ctr"/>
           <a:lstStyle/>
           <a:p>
-            <a:pPr marL="0" indent="0">
+            <a:pPr indent="0" marL="0">
               <a:lnSpc>
                 <a:spcPct val="150000"/>
               </a:lnSpc>
@@ -5715,7 +5621,7 @@
             <a:endParaRPr lang="en-US" sz="850" dirty="0"/>
           </a:p>
           <a:p>
-            <a:pPr marL="0" indent="0">
+            <a:pPr indent="0" marL="0">
               <a:lnSpc>
                 <a:spcPct val="150000"/>
               </a:lnSpc>
@@ -5735,7 +5641,7 @@
             <a:endParaRPr lang="en-US" sz="850" dirty="0"/>
           </a:p>
           <a:p>
-            <a:pPr marL="0" indent="0">
+            <a:pPr indent="0" marL="0">
               <a:lnSpc>
                 <a:spcPct val="150000"/>
               </a:lnSpc>
@@ -5755,7 +5661,7 @@
             <a:endParaRPr lang="en-US" sz="850" dirty="0"/>
           </a:p>
           <a:p>
-            <a:pPr marL="0" indent="0">
+            <a:pPr indent="0" marL="0">
               <a:lnSpc>
                 <a:spcPct val="150000"/>
               </a:lnSpc>
@@ -5775,7 +5681,7 @@
             <a:endParaRPr lang="en-US" sz="850" dirty="0"/>
           </a:p>
           <a:p>
-            <a:pPr marL="0" indent="0">
+            <a:pPr indent="0" marL="0">
               <a:lnSpc>
                 <a:spcPct val="150000"/>
               </a:lnSpc>
@@ -5815,20 +5721,13 @@
           </a:solidFill>
           <a:ln/>
           <a:effectLst>
-            <a:outerShdw blurRad="76200" dist="25400" dir="8100000" algn="bl" rotWithShape="0">
+            <a:outerShdw sx="100000" sy="100000" kx="0" ky="0" algn="bl" rotWithShape="0" blurRad="76200" dist="25400" dir="8100000">
               <a:srgbClr val="000000">
                 <a:alpha val="10000"/>
               </a:srgbClr>
             </a:outerShdw>
           </a:effectLst>
         </p:spPr>
-        <p:txBody>
-          <a:bodyPr/>
-          <a:lstStyle/>
-          <a:p>
-            <a:endParaRPr lang="en-AE"/>
-          </a:p>
-        </p:txBody>
       </p:sp>
       <p:sp>
         <p:nvSpPr>
@@ -5849,13 +5748,6 @@
           </a:solidFill>
           <a:ln/>
         </p:spPr>
-        <p:txBody>
-          <a:bodyPr/>
-          <a:lstStyle/>
-          <a:p>
-            <a:endParaRPr lang="en-AE"/>
-          </a:p>
-        </p:txBody>
       </p:sp>
       <p:sp>
         <p:nvSpPr>
@@ -5878,7 +5770,7 @@
           <a:bodyPr wrap="square" lIns="0" tIns="0" rIns="0" bIns="0" rtlCol="0" anchor="ctr"/>
           <a:lstStyle/>
           <a:p>
-            <a:pPr marL="0" indent="0">
+            <a:pPr indent="0" marL="0">
               <a:buNone/>
             </a:pPr>
             <a:r>
@@ -5895,7 +5787,7 @@
             <a:endParaRPr lang="en-US" sz="1100" dirty="0"/>
           </a:p>
           <a:p>
-            <a:pPr marL="0" indent="0">
+            <a:pPr indent="0" marL="0">
               <a:buNone/>
             </a:pPr>
             <a:r>
@@ -5935,13 +5827,6 @@
             <a:prstDash val="solid"/>
           </a:ln>
         </p:spPr>
-        <p:txBody>
-          <a:bodyPr/>
-          <a:lstStyle/>
-          <a:p>
-            <a:endParaRPr lang="en-AE"/>
-          </a:p>
-        </p:txBody>
       </p:sp>
       <p:sp>
         <p:nvSpPr>
@@ -5964,7 +5849,7 @@
           <a:bodyPr wrap="square" lIns="0" tIns="0" rIns="0" bIns="0" rtlCol="0" anchor="ctr"/>
           <a:lstStyle/>
           <a:p>
-            <a:pPr marL="0" indent="0">
+            <a:pPr indent="0" marL="0">
               <a:lnSpc>
                 <a:spcPct val="150000"/>
               </a:lnSpc>
@@ -5984,7 +5869,7 @@
             <a:endParaRPr lang="en-US" sz="850" dirty="0"/>
           </a:p>
           <a:p>
-            <a:pPr marL="0" indent="0">
+            <a:pPr indent="0" marL="0">
               <a:lnSpc>
                 <a:spcPct val="150000"/>
               </a:lnSpc>
@@ -6004,7 +5889,7 @@
             <a:endParaRPr lang="en-US" sz="850" dirty="0"/>
           </a:p>
           <a:p>
-            <a:pPr marL="0" indent="0">
+            <a:pPr indent="0" marL="0">
               <a:lnSpc>
                 <a:spcPct val="150000"/>
               </a:lnSpc>
@@ -6024,7 +5909,7 @@
             <a:endParaRPr lang="en-US" sz="850" dirty="0"/>
           </a:p>
           <a:p>
-            <a:pPr marL="0" indent="0">
+            <a:pPr indent="0" marL="0">
               <a:lnSpc>
                 <a:spcPct val="150000"/>
               </a:lnSpc>
@@ -6044,7 +5929,7 @@
             <a:endParaRPr lang="en-US" sz="850" dirty="0"/>
           </a:p>
           <a:p>
-            <a:pPr marL="0" indent="0">
+            <a:pPr indent="0" marL="0">
               <a:lnSpc>
                 <a:spcPct val="150000"/>
               </a:lnSpc>
@@ -6084,13 +5969,6 @@
           </a:solidFill>
           <a:ln/>
         </p:spPr>
-        <p:txBody>
-          <a:bodyPr/>
-          <a:lstStyle/>
-          <a:p>
-            <a:endParaRPr lang="en-AE"/>
-          </a:p>
-        </p:txBody>
       </p:sp>
     </p:spTree>
   </p:cSld>
@@ -6108,7 +5986,6 @@
         <a:solidFill>
           <a:srgbClr val="FAF6F1"/>
         </a:solidFill>
-        <a:effectLst/>
       </p:bgPr>
     </p:bg>
     <p:spTree>
@@ -6144,13 +6021,6 @@
           </a:solidFill>
           <a:ln/>
         </p:spPr>
-        <p:txBody>
-          <a:bodyPr/>
-          <a:lstStyle/>
-          <a:p>
-            <a:endParaRPr lang="en-AE"/>
-          </a:p>
-        </p:txBody>
       </p:sp>
       <p:sp>
         <p:nvSpPr>
@@ -6173,11 +6043,11 @@
           <a:bodyPr wrap="square" rtlCol="0" anchor="ctr"/>
           <a:lstStyle/>
           <a:p>
-            <a:pPr marL="0" indent="0" algn="ctr">
-              <a:buNone/>
-            </a:pPr>
-            <a:r>
-              <a:rPr lang="en-US" sz="800" b="1" kern="0" spc="300" dirty="0">
+            <a:pPr algn="ctr" indent="0" marL="0">
+              <a:buNone/>
+            </a:pPr>
+            <a:r>
+              <a:rPr lang="en-US" sz="800" b="1" spc="300" kern="0" dirty="0">
                 <a:solidFill>
                   <a:srgbClr val="F5EDE0"/>
                 </a:solidFill>
@@ -6212,11 +6082,11 @@
           <a:bodyPr wrap="square" rtlCol="0" anchor="ctr"/>
           <a:lstStyle/>
           <a:p>
-            <a:pPr marL="0" indent="0">
-              <a:buNone/>
-            </a:pPr>
-            <a:r>
-              <a:rPr lang="en-US" sz="900" b="1" kern="0" spc="300" dirty="0">
+            <a:pPr indent="0" marL="0">
+              <a:buNone/>
+            </a:pPr>
+            <a:r>
+              <a:rPr lang="en-US" sz="900" b="1" spc="300" kern="0" dirty="0">
                 <a:solidFill>
                   <a:srgbClr val="006B5E"/>
                 </a:solidFill>
@@ -6252,13 +6122,6 @@
             <a:prstDash val="solid"/>
           </a:ln>
         </p:spPr>
-        <p:txBody>
-          <a:bodyPr/>
-          <a:lstStyle/>
-          <a:p>
-            <a:endParaRPr lang="en-AE"/>
-          </a:p>
-        </p:txBody>
       </p:sp>
       <p:sp>
         <p:nvSpPr>
@@ -6281,7 +6144,7 @@
           <a:bodyPr wrap="square" lIns="0" tIns="0" rIns="0" bIns="0" rtlCol="0" anchor="ctr"/>
           <a:lstStyle/>
           <a:p>
-            <a:pPr marL="0" indent="0">
+            <a:pPr indent="0" marL="0">
               <a:buNone/>
             </a:pPr>
             <a:r>
@@ -6318,13 +6181,6 @@
           </a:solidFill>
           <a:ln/>
         </p:spPr>
-        <p:txBody>
-          <a:bodyPr/>
-          <a:lstStyle/>
-          <a:p>
-            <a:endParaRPr lang="en-AE"/>
-          </a:p>
-        </p:txBody>
       </p:sp>
       <p:sp>
         <p:nvSpPr>
@@ -6347,7 +6203,7 @@
           <a:bodyPr wrap="square" rtlCol="0" anchor="ctr"/>
           <a:lstStyle/>
           <a:p>
-            <a:pPr marL="0" indent="0">
+            <a:pPr indent="0" marL="0">
               <a:buNone/>
             </a:pPr>
             <a:r>
@@ -6386,7 +6242,7 @@
           <a:bodyPr wrap="square" rtlCol="0" anchor="ctr"/>
           <a:lstStyle/>
           <a:p>
-            <a:pPr marL="0" indent="0" algn="r">
+            <a:pPr algn="r" indent="0" marL="0">
               <a:buNone/>
             </a:pPr>
             <a:r>
@@ -6425,7 +6281,7 @@
           <a:bodyPr wrap="square" rtlCol="0" anchor="ctr"/>
           <a:lstStyle/>
           <a:p>
-            <a:pPr marL="0" indent="0">
+            <a:pPr indent="0" marL="0">
               <a:lnSpc>
                 <a:spcPct val="140000"/>
               </a:lnSpc>
@@ -6465,20 +6321,13 @@
           </a:solidFill>
           <a:ln/>
           <a:effectLst>
-            <a:outerShdw blurRad="76200" dist="25400" dir="8100000" algn="bl" rotWithShape="0">
+            <a:outerShdw sx="100000" sy="100000" kx="0" ky="0" algn="bl" rotWithShape="0" blurRad="76200" dist="25400" dir="8100000">
               <a:srgbClr val="000000">
                 <a:alpha val="10000"/>
               </a:srgbClr>
             </a:outerShdw>
           </a:effectLst>
         </p:spPr>
-        <p:txBody>
-          <a:bodyPr/>
-          <a:lstStyle/>
-          <a:p>
-            <a:endParaRPr lang="en-AE"/>
-          </a:p>
-        </p:txBody>
       </p:sp>
       <p:sp>
         <p:nvSpPr>
@@ -6499,13 +6348,6 @@
           </a:solidFill>
           <a:ln/>
         </p:spPr>
-        <p:txBody>
-          <a:bodyPr/>
-          <a:lstStyle/>
-          <a:p>
-            <a:endParaRPr lang="en-AE"/>
-          </a:p>
-        </p:txBody>
       </p:sp>
       <p:sp>
         <p:nvSpPr>
@@ -6528,7 +6370,7 @@
           <a:bodyPr wrap="square" rtlCol="0" anchor="ctr"/>
           <a:lstStyle/>
           <a:p>
-            <a:pPr marL="0" indent="0" algn="ctr">
+            <a:pPr algn="ctr" indent="0" marL="0">
               <a:buNone/>
             </a:pPr>
             <a:r>
@@ -6567,7 +6409,7 @@
           <a:bodyPr wrap="square" lIns="0" tIns="0" rIns="0" bIns="0" rtlCol="0" anchor="ctr"/>
           <a:lstStyle/>
           <a:p>
-            <a:pPr marL="0" indent="0">
+            <a:pPr indent="0" marL="0">
               <a:lnSpc>
                 <a:spcPct val="130000"/>
               </a:lnSpc>
@@ -6609,7 +6451,7 @@
           <a:bodyPr wrap="square" lIns="0" tIns="0" rIns="0" bIns="0" rtlCol="0" anchor="ctr"/>
           <a:lstStyle/>
           <a:p>
-            <a:pPr marL="0" indent="0">
+            <a:pPr indent="0" marL="0">
               <a:lnSpc>
                 <a:spcPct val="120000"/>
               </a:lnSpc>
@@ -6626,49 +6468,55 @@
               </a:rPr>
               <a:t>Best for: </a:t>
             </a:r>
-            <a:r>
-              <a:rPr lang="en-US" sz="850" dirty="0">
-                <a:solidFill>
-                  <a:srgbClr val="5A6B7F"/>
-                </a:solidFill>
-                <a:latin typeface="Arial" pitchFamily="34" charset="0"/>
-                <a:ea typeface="Arial" pitchFamily="34" charset="-122"/>
-                <a:cs typeface="Arial" pitchFamily="34" charset="-120"/>
-              </a:rPr>
-              <a:t>Consistency, control, regulatory confidence, standardisation</a:t>
-            </a:r>
-            <a:endParaRPr lang="en-US" sz="850" dirty="0"/>
-          </a:p>
-        </p:txBody>
-      </p:sp>
-      <p:sp>
-        <p:nvSpPr>
-          <p:cNvPr id="16" name="Text 14"/>
-          <p:cNvSpPr/>
-          <p:nvPr/>
-        </p:nvSpPr>
-        <p:spPr>
-          <a:xfrm>
-            <a:off x="777240" y="3749040"/>
-            <a:ext cx="2286000" cy="502920"/>
-          </a:xfrm>
-          <a:prstGeom prst="rect">
-            <a:avLst/>
-          </a:prstGeom>
-          <a:noFill/>
-          <a:ln/>
-        </p:spPr>
-        <p:txBody>
-          <a:bodyPr wrap="square" lIns="0" tIns="0" rIns="0" bIns="0" rtlCol="0" anchor="ctr"/>
-          <a:lstStyle/>
-          <a:p>
-            <a:pPr marL="0" indent="0">
+            <a:pPr indent="0" marL="0">
               <a:lnSpc>
                 <a:spcPct val="120000"/>
               </a:lnSpc>
               <a:buNone/>
             </a:pPr>
             <a:r>
+              <a:rPr lang="en-US" sz="850" dirty="0">
+                <a:solidFill>
+                  <a:srgbClr val="5A6B7F"/>
+                </a:solidFill>
+                <a:latin typeface="Arial" pitchFamily="34" charset="0"/>
+                <a:ea typeface="Arial" pitchFamily="34" charset="-122"/>
+                <a:cs typeface="Arial" pitchFamily="34" charset="-120"/>
+              </a:rPr>
+              <a:t>Consistency, control, regulatory confidence, standardisation</a:t>
+            </a:r>
+            <a:endParaRPr lang="en-US" sz="850" dirty="0"/>
+          </a:p>
+        </p:txBody>
+      </p:sp>
+      <p:sp>
+        <p:nvSpPr>
+          <p:cNvPr id="16" name="Text 14"/>
+          <p:cNvSpPr/>
+          <p:nvPr/>
+        </p:nvSpPr>
+        <p:spPr>
+          <a:xfrm>
+            <a:off x="777240" y="3749040"/>
+            <a:ext cx="2286000" cy="502920"/>
+          </a:xfrm>
+          <a:prstGeom prst="rect">
+            <a:avLst/>
+          </a:prstGeom>
+          <a:noFill/>
+          <a:ln/>
+        </p:spPr>
+        <p:txBody>
+          <a:bodyPr wrap="square" lIns="0" tIns="0" rIns="0" bIns="0" rtlCol="0" anchor="ctr"/>
+          <a:lstStyle/>
+          <a:p>
+            <a:pPr indent="0" marL="0">
+              <a:lnSpc>
+                <a:spcPct val="120000"/>
+              </a:lnSpc>
+              <a:buNone/>
+            </a:pPr>
+            <a:r>
               <a:rPr lang="en-US" sz="850" b="1" dirty="0">
                 <a:solidFill>
                   <a:srgbClr val="C0392B"/>
@@ -6679,6 +6527,12 @@
               </a:rPr>
               <a:t>Risk: </a:t>
             </a:r>
+            <a:pPr indent="0" marL="0">
+              <a:lnSpc>
+                <a:spcPct val="120000"/>
+              </a:lnSpc>
+              <a:buNone/>
+            </a:pPr>
             <a:r>
               <a:rPr lang="en-US" sz="850" dirty="0">
                 <a:solidFill>
@@ -6713,20 +6567,13 @@
           </a:solidFill>
           <a:ln/>
           <a:effectLst>
-            <a:outerShdw blurRad="76200" dist="25400" dir="8100000" algn="bl" rotWithShape="0">
+            <a:outerShdw sx="100000" sy="100000" kx="0" ky="0" algn="bl" rotWithShape="0" blurRad="76200" dist="25400" dir="8100000">
               <a:srgbClr val="000000">
                 <a:alpha val="10000"/>
               </a:srgbClr>
             </a:outerShdw>
           </a:effectLst>
         </p:spPr>
-        <p:txBody>
-          <a:bodyPr/>
-          <a:lstStyle/>
-          <a:p>
-            <a:endParaRPr lang="en-AE"/>
-          </a:p>
-        </p:txBody>
       </p:sp>
       <p:sp>
         <p:nvSpPr>
@@ -6747,13 +6594,6 @@
           </a:solidFill>
           <a:ln/>
         </p:spPr>
-        <p:txBody>
-          <a:bodyPr/>
-          <a:lstStyle/>
-          <a:p>
-            <a:endParaRPr lang="en-AE"/>
-          </a:p>
-        </p:txBody>
       </p:sp>
       <p:sp>
         <p:nvSpPr>
@@ -6776,7 +6616,7 @@
           <a:bodyPr wrap="square" rtlCol="0" anchor="ctr"/>
           <a:lstStyle/>
           <a:p>
-            <a:pPr marL="0" indent="0" algn="ctr">
+            <a:pPr algn="ctr" indent="0" marL="0">
               <a:buNone/>
             </a:pPr>
             <a:r>
@@ -6815,7 +6655,7 @@
           <a:bodyPr wrap="square" lIns="0" tIns="0" rIns="0" bIns="0" rtlCol="0" anchor="ctr"/>
           <a:lstStyle/>
           <a:p>
-            <a:pPr marL="0" indent="0">
+            <a:pPr indent="0" marL="0">
               <a:lnSpc>
                 <a:spcPct val="130000"/>
               </a:lnSpc>
@@ -6857,7 +6697,7 @@
           <a:bodyPr wrap="square" lIns="0" tIns="0" rIns="0" bIns="0" rtlCol="0" anchor="ctr"/>
           <a:lstStyle/>
           <a:p>
-            <a:pPr marL="0" indent="0">
+            <a:pPr indent="0" marL="0">
               <a:lnSpc>
                 <a:spcPct val="120000"/>
               </a:lnSpc>
@@ -6874,49 +6714,55 @@
               </a:rPr>
               <a:t>Best for: </a:t>
             </a:r>
-            <a:r>
-              <a:rPr lang="en-US" sz="850" dirty="0">
-                <a:solidFill>
-                  <a:srgbClr val="5A6B7F"/>
-                </a:solidFill>
-                <a:latin typeface="Arial" pitchFamily="34" charset="0"/>
-                <a:ea typeface="Arial" pitchFamily="34" charset="-122"/>
-                <a:cs typeface="Arial" pitchFamily="34" charset="-120"/>
-              </a:rPr>
-              <a:t>Balancing enterprise control with business ownership</a:t>
-            </a:r>
-            <a:endParaRPr lang="en-US" sz="850" dirty="0"/>
-          </a:p>
-        </p:txBody>
-      </p:sp>
-      <p:sp>
-        <p:nvSpPr>
-          <p:cNvPr id="22" name="Text 20"/>
-          <p:cNvSpPr/>
-          <p:nvPr/>
-        </p:nvSpPr>
-        <p:spPr>
-          <a:xfrm>
-            <a:off x="3566160" y="3749040"/>
-            <a:ext cx="2286000" cy="502920"/>
-          </a:xfrm>
-          <a:prstGeom prst="rect">
-            <a:avLst/>
-          </a:prstGeom>
-          <a:noFill/>
-          <a:ln/>
-        </p:spPr>
-        <p:txBody>
-          <a:bodyPr wrap="square" lIns="0" tIns="0" rIns="0" bIns="0" rtlCol="0" anchor="ctr"/>
-          <a:lstStyle/>
-          <a:p>
-            <a:pPr marL="0" indent="0">
+            <a:pPr indent="0" marL="0">
               <a:lnSpc>
                 <a:spcPct val="120000"/>
               </a:lnSpc>
               <a:buNone/>
             </a:pPr>
             <a:r>
+              <a:rPr lang="en-US" sz="850" dirty="0">
+                <a:solidFill>
+                  <a:srgbClr val="5A6B7F"/>
+                </a:solidFill>
+                <a:latin typeface="Arial" pitchFamily="34" charset="0"/>
+                <a:ea typeface="Arial" pitchFamily="34" charset="-122"/>
+                <a:cs typeface="Arial" pitchFamily="34" charset="-120"/>
+              </a:rPr>
+              <a:t>Balancing enterprise control with business ownership</a:t>
+            </a:r>
+            <a:endParaRPr lang="en-US" sz="850" dirty="0"/>
+          </a:p>
+        </p:txBody>
+      </p:sp>
+      <p:sp>
+        <p:nvSpPr>
+          <p:cNvPr id="22" name="Text 20"/>
+          <p:cNvSpPr/>
+          <p:nvPr/>
+        </p:nvSpPr>
+        <p:spPr>
+          <a:xfrm>
+            <a:off x="3566160" y="3749040"/>
+            <a:ext cx="2286000" cy="502920"/>
+          </a:xfrm>
+          <a:prstGeom prst="rect">
+            <a:avLst/>
+          </a:prstGeom>
+          <a:noFill/>
+          <a:ln/>
+        </p:spPr>
+        <p:txBody>
+          <a:bodyPr wrap="square" lIns="0" tIns="0" rIns="0" bIns="0" rtlCol="0" anchor="ctr"/>
+          <a:lstStyle/>
+          <a:p>
+            <a:pPr indent="0" marL="0">
+              <a:lnSpc>
+                <a:spcPct val="120000"/>
+              </a:lnSpc>
+              <a:buNone/>
+            </a:pPr>
+            <a:r>
               <a:rPr lang="en-US" sz="850" b="1" dirty="0">
                 <a:solidFill>
                   <a:srgbClr val="C0392B"/>
@@ -6927,6 +6773,12 @@
               </a:rPr>
               <a:t>Risk: </a:t>
             </a:r>
+            <a:pPr indent="0" marL="0">
+              <a:lnSpc>
+                <a:spcPct val="120000"/>
+              </a:lnSpc>
+              <a:buNone/>
+            </a:pPr>
             <a:r>
               <a:rPr lang="en-US" sz="850" dirty="0">
                 <a:solidFill>
@@ -6963,11 +6815,11 @@
           <a:bodyPr wrap="square" rtlCol="0" anchor="ctr"/>
           <a:lstStyle/>
           <a:p>
-            <a:pPr marL="0" indent="0" algn="ctr">
-              <a:buNone/>
-            </a:pPr>
-            <a:r>
-              <a:rPr lang="en-US" sz="800" b="1" kern="0" spc="200" dirty="0">
+            <a:pPr algn="ctr" indent="0" marL="0">
+              <a:buNone/>
+            </a:pPr>
+            <a:r>
+              <a:rPr lang="en-US" sz="800" b="1" spc="200" kern="0" dirty="0">
                 <a:solidFill>
                   <a:srgbClr val="006B5E"/>
                 </a:solidFill>
@@ -7000,20 +6852,13 @@
           </a:solidFill>
           <a:ln/>
           <a:effectLst>
-            <a:outerShdw blurRad="76200" dist="25400" dir="8100000" algn="bl" rotWithShape="0">
+            <a:outerShdw sx="100000" sy="100000" kx="0" ky="0" algn="bl" rotWithShape="0" blurRad="76200" dist="25400" dir="8100000">
               <a:srgbClr val="000000">
                 <a:alpha val="10000"/>
               </a:srgbClr>
             </a:outerShdw>
           </a:effectLst>
         </p:spPr>
-        <p:txBody>
-          <a:bodyPr/>
-          <a:lstStyle/>
-          <a:p>
-            <a:endParaRPr lang="en-AE"/>
-          </a:p>
-        </p:txBody>
       </p:sp>
       <p:sp>
         <p:nvSpPr>
@@ -7034,13 +6879,6 @@
           </a:solidFill>
           <a:ln/>
         </p:spPr>
-        <p:txBody>
-          <a:bodyPr/>
-          <a:lstStyle/>
-          <a:p>
-            <a:endParaRPr lang="en-AE"/>
-          </a:p>
-        </p:txBody>
       </p:sp>
       <p:sp>
         <p:nvSpPr>
@@ -7063,7 +6901,7 @@
           <a:bodyPr wrap="square" rtlCol="0" anchor="ctr"/>
           <a:lstStyle/>
           <a:p>
-            <a:pPr marL="0" indent="0" algn="ctr">
+            <a:pPr algn="ctr" indent="0" marL="0">
               <a:buNone/>
             </a:pPr>
             <a:r>
@@ -7102,7 +6940,7 @@
           <a:bodyPr wrap="square" lIns="0" tIns="0" rIns="0" bIns="0" rtlCol="0" anchor="ctr"/>
           <a:lstStyle/>
           <a:p>
-            <a:pPr marL="0" indent="0">
+            <a:pPr indent="0" marL="0">
               <a:lnSpc>
                 <a:spcPct val="130000"/>
               </a:lnSpc>
@@ -7144,7 +6982,7 @@
           <a:bodyPr wrap="square" lIns="0" tIns="0" rIns="0" bIns="0" rtlCol="0" anchor="ctr"/>
           <a:lstStyle/>
           <a:p>
-            <a:pPr marL="0" indent="0">
+            <a:pPr indent="0" marL="0">
               <a:lnSpc>
                 <a:spcPct val="120000"/>
               </a:lnSpc>
@@ -7161,49 +6999,55 @@
               </a:rPr>
               <a:t>Best for: </a:t>
             </a:r>
-            <a:r>
-              <a:rPr lang="en-US" sz="850" dirty="0">
-                <a:solidFill>
-                  <a:srgbClr val="5A6B7F"/>
-                </a:solidFill>
-                <a:latin typeface="Arial" pitchFamily="34" charset="0"/>
-                <a:ea typeface="Arial" pitchFamily="34" charset="-122"/>
-                <a:cs typeface="Arial" pitchFamily="34" charset="-120"/>
-              </a:rPr>
-              <a:t>Speed, business proximity, local ownership, tailored solutions</a:t>
-            </a:r>
-            <a:endParaRPr lang="en-US" sz="850" dirty="0"/>
-          </a:p>
-        </p:txBody>
-      </p:sp>
-      <p:sp>
-        <p:nvSpPr>
-          <p:cNvPr id="29" name="Text 27"/>
-          <p:cNvSpPr/>
-          <p:nvPr/>
-        </p:nvSpPr>
-        <p:spPr>
-          <a:xfrm>
-            <a:off x="6355080" y="3749040"/>
-            <a:ext cx="2286000" cy="502920"/>
-          </a:xfrm>
-          <a:prstGeom prst="rect">
-            <a:avLst/>
-          </a:prstGeom>
-          <a:noFill/>
-          <a:ln/>
-        </p:spPr>
-        <p:txBody>
-          <a:bodyPr wrap="square" lIns="0" tIns="0" rIns="0" bIns="0" rtlCol="0" anchor="ctr"/>
-          <a:lstStyle/>
-          <a:p>
-            <a:pPr marL="0" indent="0">
+            <a:pPr indent="0" marL="0">
               <a:lnSpc>
                 <a:spcPct val="120000"/>
               </a:lnSpc>
               <a:buNone/>
             </a:pPr>
             <a:r>
+              <a:rPr lang="en-US" sz="850" dirty="0">
+                <a:solidFill>
+                  <a:srgbClr val="5A6B7F"/>
+                </a:solidFill>
+                <a:latin typeface="Arial" pitchFamily="34" charset="0"/>
+                <a:ea typeface="Arial" pitchFamily="34" charset="-122"/>
+                <a:cs typeface="Arial" pitchFamily="34" charset="-120"/>
+              </a:rPr>
+              <a:t>Speed, business proximity, local ownership, tailored solutions</a:t>
+            </a:r>
+            <a:endParaRPr lang="en-US" sz="850" dirty="0"/>
+          </a:p>
+        </p:txBody>
+      </p:sp>
+      <p:sp>
+        <p:nvSpPr>
+          <p:cNvPr id="29" name="Text 27"/>
+          <p:cNvSpPr/>
+          <p:nvPr/>
+        </p:nvSpPr>
+        <p:spPr>
+          <a:xfrm>
+            <a:off x="6355080" y="3749040"/>
+            <a:ext cx="2286000" cy="502920"/>
+          </a:xfrm>
+          <a:prstGeom prst="rect">
+            <a:avLst/>
+          </a:prstGeom>
+          <a:noFill/>
+          <a:ln/>
+        </p:spPr>
+        <p:txBody>
+          <a:bodyPr wrap="square" lIns="0" tIns="0" rIns="0" bIns="0" rtlCol="0" anchor="ctr"/>
+          <a:lstStyle/>
+          <a:p>
+            <a:pPr indent="0" marL="0">
+              <a:lnSpc>
+                <a:spcPct val="120000"/>
+              </a:lnSpc>
+              <a:buNone/>
+            </a:pPr>
+            <a:r>
               <a:rPr lang="en-US" sz="850" b="1" dirty="0">
                 <a:solidFill>
                   <a:srgbClr val="C0392B"/>
@@ -7214,6 +7058,12 @@
               </a:rPr>
               <a:t>Risk: </a:t>
             </a:r>
+            <a:pPr indent="0" marL="0">
+              <a:lnSpc>
+                <a:spcPct val="120000"/>
+              </a:lnSpc>
+              <a:buNone/>
+            </a:pPr>
             <a:r>
               <a:rPr lang="en-US" sz="850" dirty="0">
                 <a:solidFill>
@@ -7245,7 +7095,6 @@
         <a:solidFill>
           <a:srgbClr val="FAF6F1"/>
         </a:solidFill>
-        <a:effectLst/>
       </p:bgPr>
     </p:bg>
     <p:spTree>
@@ -7281,13 +7130,6 @@
           </a:solidFill>
           <a:ln/>
         </p:spPr>
-        <p:txBody>
-          <a:bodyPr/>
-          <a:lstStyle/>
-          <a:p>
-            <a:endParaRPr lang="en-AE"/>
-          </a:p>
-        </p:txBody>
       </p:sp>
       <p:sp>
         <p:nvSpPr>
@@ -7310,11 +7152,11 @@
           <a:bodyPr wrap="square" rtlCol="0" anchor="ctr"/>
           <a:lstStyle/>
           <a:p>
-            <a:pPr marL="0" indent="0" algn="ctr">
-              <a:buNone/>
-            </a:pPr>
-            <a:r>
-              <a:rPr lang="en-US" sz="800" b="1" kern="0" spc="300" dirty="0">
+            <a:pPr algn="ctr" indent="0" marL="0">
+              <a:buNone/>
+            </a:pPr>
+            <a:r>
+              <a:rPr lang="en-US" sz="800" b="1" spc="300" kern="0" dirty="0">
                 <a:solidFill>
                   <a:srgbClr val="F5EDE0"/>
                 </a:solidFill>
@@ -7349,11 +7191,11 @@
           <a:bodyPr wrap="square" rtlCol="0" anchor="ctr"/>
           <a:lstStyle/>
           <a:p>
-            <a:pPr marL="0" indent="0">
-              <a:buNone/>
-            </a:pPr>
-            <a:r>
-              <a:rPr lang="en-US" sz="900" b="1" kern="0" spc="300" dirty="0">
+            <a:pPr indent="0" marL="0">
+              <a:buNone/>
+            </a:pPr>
+            <a:r>
+              <a:rPr lang="en-US" sz="900" b="1" spc="300" kern="0" dirty="0">
                 <a:solidFill>
                   <a:srgbClr val="006B5E"/>
                 </a:solidFill>
@@ -7389,13 +7231,6 @@
             <a:prstDash val="solid"/>
           </a:ln>
         </p:spPr>
-        <p:txBody>
-          <a:bodyPr/>
-          <a:lstStyle/>
-          <a:p>
-            <a:endParaRPr lang="en-AE"/>
-          </a:p>
-        </p:txBody>
       </p:sp>
       <p:sp>
         <p:nvSpPr>
@@ -7418,7 +7253,7 @@
           <a:bodyPr wrap="square" lIns="0" tIns="0" rIns="0" bIns="0" rtlCol="0" anchor="ctr"/>
           <a:lstStyle/>
           <a:p>
-            <a:pPr marL="0" indent="0">
+            <a:pPr indent="0" marL="0">
               <a:buNone/>
             </a:pPr>
             <a:r>
@@ -7455,13 +7290,6 @@
           </a:solidFill>
           <a:ln/>
         </p:spPr>
-        <p:txBody>
-          <a:bodyPr/>
-          <a:lstStyle/>
-          <a:p>
-            <a:endParaRPr lang="en-AE"/>
-          </a:p>
-        </p:txBody>
       </p:sp>
       <p:sp>
         <p:nvSpPr>
@@ -7484,7 +7312,7 @@
           <a:bodyPr wrap="square" rtlCol="0" anchor="ctr"/>
           <a:lstStyle/>
           <a:p>
-            <a:pPr marL="0" indent="0">
+            <a:pPr indent="0" marL="0">
               <a:buNone/>
             </a:pPr>
             <a:r>
@@ -7523,7 +7351,7 @@
           <a:bodyPr wrap="square" rtlCol="0" anchor="ctr"/>
           <a:lstStyle/>
           <a:p>
-            <a:pPr marL="0" indent="0" algn="r">
+            <a:pPr algn="r" indent="0" marL="0">
               <a:buNone/>
             </a:pPr>
             <a:r>
@@ -7562,7 +7390,7 @@
           <a:bodyPr wrap="square" rtlCol="0" anchor="ctr"/>
           <a:lstStyle/>
           <a:p>
-            <a:pPr marL="0" indent="0">
+            <a:pPr indent="0" marL="0">
               <a:buNone/>
             </a:pPr>
             <a:r>
@@ -7604,13 +7432,6 @@
             <a:prstDash val="solid"/>
           </a:ln>
         </p:spPr>
-        <p:txBody>
-          <a:bodyPr/>
-          <a:lstStyle/>
-          <a:p>
-            <a:endParaRPr lang="en-AE"/>
-          </a:p>
-        </p:txBody>
       </p:sp>
       <p:sp>
         <p:nvSpPr>
@@ -7633,7 +7454,7 @@
           <a:bodyPr wrap="square" rtlCol="0" anchor="ctr"/>
           <a:lstStyle/>
           <a:p>
-            <a:pPr marL="0" indent="0" algn="ctr">
+            <a:pPr algn="ctr" indent="0" marL="0">
               <a:buNone/>
             </a:pPr>
             <a:r>
@@ -7675,13 +7496,6 @@
             <a:prstDash val="solid"/>
           </a:ln>
         </p:spPr>
-        <p:txBody>
-          <a:bodyPr/>
-          <a:lstStyle/>
-          <a:p>
-            <a:endParaRPr lang="en-AE"/>
-          </a:p>
-        </p:txBody>
       </p:sp>
       <p:sp>
         <p:nvSpPr>
@@ -7704,7 +7518,7 @@
           <a:bodyPr wrap="square" rtlCol="0" anchor="ctr"/>
           <a:lstStyle/>
           <a:p>
-            <a:pPr marL="0" indent="0" algn="ctr">
+            <a:pPr algn="ctr" indent="0" marL="0">
               <a:buNone/>
             </a:pPr>
             <a:r>
@@ -7746,13 +7560,6 @@
             <a:prstDash val="solid"/>
           </a:ln>
         </p:spPr>
-        <p:txBody>
-          <a:bodyPr/>
-          <a:lstStyle/>
-          <a:p>
-            <a:endParaRPr lang="en-AE"/>
-          </a:p>
-        </p:txBody>
       </p:sp>
       <p:sp>
         <p:nvSpPr>
@@ -7775,7 +7582,7 @@
           <a:bodyPr wrap="square" rtlCol="0" anchor="ctr"/>
           <a:lstStyle/>
           <a:p>
-            <a:pPr marL="0" indent="0" algn="ctr">
+            <a:pPr algn="ctr" indent="0" marL="0">
               <a:buNone/>
             </a:pPr>
             <a:r>
@@ -7817,13 +7624,6 @@
             <a:prstDash val="solid"/>
           </a:ln>
         </p:spPr>
-        <p:txBody>
-          <a:bodyPr/>
-          <a:lstStyle/>
-          <a:p>
-            <a:endParaRPr lang="en-AE"/>
-          </a:p>
-        </p:txBody>
       </p:sp>
       <p:sp>
         <p:nvSpPr>
@@ -7846,7 +7646,7 @@
           <a:bodyPr wrap="square" rtlCol="0" anchor="ctr"/>
           <a:lstStyle/>
           <a:p>
-            <a:pPr marL="0" indent="0" algn="ctr">
+            <a:pPr algn="ctr" indent="0" marL="0">
               <a:buNone/>
             </a:pPr>
             <a:r>
@@ -7888,13 +7688,6 @@
             <a:prstDash val="solid"/>
           </a:ln>
         </p:spPr>
-        <p:txBody>
-          <a:bodyPr/>
-          <a:lstStyle/>
-          <a:p>
-            <a:endParaRPr lang="en-AE"/>
-          </a:p>
-        </p:txBody>
       </p:sp>
       <p:sp>
         <p:nvSpPr>
@@ -7917,7 +7710,7 @@
           <a:bodyPr wrap="square" rtlCol="0" anchor="ctr"/>
           <a:lstStyle/>
           <a:p>
-            <a:pPr marL="0" indent="0" algn="ctr">
+            <a:pPr algn="ctr" indent="0" marL="0">
               <a:buNone/>
             </a:pPr>
             <a:r>
@@ -7959,13 +7752,6 @@
             <a:prstDash val="solid"/>
           </a:ln>
         </p:spPr>
-        <p:txBody>
-          <a:bodyPr/>
-          <a:lstStyle/>
-          <a:p>
-            <a:endParaRPr lang="en-AE"/>
-          </a:p>
-        </p:txBody>
       </p:sp>
       <p:sp>
         <p:nvSpPr>
@@ -7988,7 +7774,7 @@
           <a:bodyPr wrap="square" rtlCol="0" anchor="ctr"/>
           <a:lstStyle/>
           <a:p>
-            <a:pPr marL="0" indent="0" algn="ctr">
+            <a:pPr algn="ctr" indent="0" marL="0">
               <a:buNone/>
             </a:pPr>
             <a:r>
@@ -8030,13 +7816,6 @@
             <a:prstDash val="solid"/>
           </a:ln>
         </p:spPr>
-        <p:txBody>
-          <a:bodyPr/>
-          <a:lstStyle/>
-          <a:p>
-            <a:endParaRPr lang="en-AE"/>
-          </a:p>
-        </p:txBody>
       </p:sp>
       <p:sp>
         <p:nvSpPr>
@@ -8059,7 +7838,7 @@
           <a:bodyPr wrap="square" rtlCol="0" anchor="ctr"/>
           <a:lstStyle/>
           <a:p>
-            <a:pPr marL="0" indent="0" algn="ctr">
+            <a:pPr algn="ctr" indent="0" marL="0">
               <a:buNone/>
             </a:pPr>
             <a:r>
@@ -8101,13 +7880,6 @@
             <a:prstDash val="solid"/>
           </a:ln>
         </p:spPr>
-        <p:txBody>
-          <a:bodyPr/>
-          <a:lstStyle/>
-          <a:p>
-            <a:endParaRPr lang="en-AE"/>
-          </a:p>
-        </p:txBody>
       </p:sp>
       <p:sp>
         <p:nvSpPr>
@@ -8130,7 +7902,7 @@
           <a:bodyPr wrap="square" rtlCol="0" anchor="ctr"/>
           <a:lstStyle/>
           <a:p>
-            <a:pPr marL="0" indent="0" algn="ctr">
+            <a:pPr algn="ctr" indent="0" marL="0">
               <a:buNone/>
             </a:pPr>
             <a:r>
@@ -8172,13 +7944,6 @@
             <a:prstDash val="solid"/>
           </a:ln>
         </p:spPr>
-        <p:txBody>
-          <a:bodyPr/>
-          <a:lstStyle/>
-          <a:p>
-            <a:endParaRPr lang="en-AE"/>
-          </a:p>
-        </p:txBody>
       </p:sp>
       <p:sp>
         <p:nvSpPr>
@@ -8201,7 +7966,7 @@
           <a:bodyPr wrap="square" rtlCol="0" anchor="ctr"/>
           <a:lstStyle/>
           <a:p>
-            <a:pPr marL="0" indent="0" algn="ctr">
+            <a:pPr algn="ctr" indent="0" marL="0">
               <a:buNone/>
             </a:pPr>
             <a:r>
@@ -8243,13 +8008,6 @@
             <a:prstDash val="solid"/>
           </a:ln>
         </p:spPr>
-        <p:txBody>
-          <a:bodyPr/>
-          <a:lstStyle/>
-          <a:p>
-            <a:endParaRPr lang="en-AE"/>
-          </a:p>
-        </p:txBody>
       </p:sp>
       <p:sp>
         <p:nvSpPr>
@@ -8272,7 +8030,7 @@
           <a:bodyPr wrap="square" rtlCol="0" anchor="ctr"/>
           <a:lstStyle/>
           <a:p>
-            <a:pPr marL="0" indent="0" algn="ctr">
+            <a:pPr algn="ctr" indent="0" marL="0">
               <a:buNone/>
             </a:pPr>
             <a:r>
@@ -8314,13 +8072,6 @@
             <a:prstDash val="solid"/>
           </a:ln>
         </p:spPr>
-        <p:txBody>
-          <a:bodyPr/>
-          <a:lstStyle/>
-          <a:p>
-            <a:endParaRPr lang="en-AE"/>
-          </a:p>
-        </p:txBody>
       </p:sp>
       <p:sp>
         <p:nvSpPr>
@@ -8343,7 +8094,7 @@
           <a:bodyPr wrap="square" rtlCol="0" anchor="ctr"/>
           <a:lstStyle/>
           <a:p>
-            <a:pPr marL="0" indent="0" algn="ctr">
+            <a:pPr algn="ctr" indent="0" marL="0">
               <a:buNone/>
             </a:pPr>
             <a:r>
@@ -8385,13 +8136,6 @@
             <a:prstDash val="solid"/>
           </a:ln>
         </p:spPr>
-        <p:txBody>
-          <a:bodyPr/>
-          <a:lstStyle/>
-          <a:p>
-            <a:endParaRPr lang="en-AE"/>
-          </a:p>
-        </p:txBody>
       </p:sp>
       <p:sp>
         <p:nvSpPr>
@@ -8414,7 +8158,7 @@
           <a:bodyPr wrap="square" rtlCol="0" anchor="ctr"/>
           <a:lstStyle/>
           <a:p>
-            <a:pPr marL="0" indent="0" algn="ctr">
+            <a:pPr algn="ctr" indent="0" marL="0">
               <a:buNone/>
             </a:pPr>
             <a:r>
@@ -8453,7 +8197,7 @@
           <a:bodyPr wrap="square" lIns="0" tIns="0" rIns="0" bIns="0" rtlCol="0" anchor="ctr"/>
           <a:lstStyle/>
           <a:p>
-            <a:pPr marL="0" indent="0">
+            <a:pPr indent="0" marL="0">
               <a:buNone/>
             </a:pPr>
             <a:r>
@@ -8495,13 +8239,6 @@
             <a:prstDash val="solid"/>
           </a:ln>
         </p:spPr>
-        <p:txBody>
-          <a:bodyPr/>
-          <a:lstStyle/>
-          <a:p>
-            <a:endParaRPr lang="en-AE"/>
-          </a:p>
-        </p:txBody>
       </p:sp>
       <p:sp>
         <p:nvSpPr>
@@ -8524,7 +8261,7 @@
           <a:bodyPr wrap="square" lIns="0" tIns="0" rIns="0" bIns="0" rtlCol="0" anchor="ctr"/>
           <a:lstStyle/>
           <a:p>
-            <a:pPr marL="0" indent="0">
+            <a:pPr indent="0" marL="0">
               <a:buNone/>
             </a:pPr>
             <a:r>
@@ -8563,7 +8300,7 @@
           <a:bodyPr wrap="square" lIns="0" tIns="0" rIns="0" bIns="0" rtlCol="0" anchor="ctr"/>
           <a:lstStyle/>
           <a:p>
-            <a:pPr marL="0" indent="0">
+            <a:pPr indent="0" marL="0">
               <a:buNone/>
             </a:pPr>
             <a:r>
@@ -8605,13 +8342,6 @@
             <a:prstDash val="solid"/>
           </a:ln>
         </p:spPr>
-        <p:txBody>
-          <a:bodyPr/>
-          <a:lstStyle/>
-          <a:p>
-            <a:endParaRPr lang="en-AE"/>
-          </a:p>
-        </p:txBody>
       </p:sp>
       <p:sp>
         <p:nvSpPr>
@@ -8634,7 +8364,7 @@
           <a:bodyPr wrap="square" lIns="0" tIns="0" rIns="0" bIns="0" rtlCol="0" anchor="ctr"/>
           <a:lstStyle/>
           <a:p>
-            <a:pPr marL="0" indent="0">
+            <a:pPr indent="0" marL="0">
               <a:buNone/>
             </a:pPr>
             <a:r>
@@ -8673,7 +8403,7 @@
           <a:bodyPr wrap="square" lIns="0" tIns="0" rIns="0" bIns="0" rtlCol="0" anchor="ctr"/>
           <a:lstStyle/>
           <a:p>
-            <a:pPr marL="0" indent="0">
+            <a:pPr indent="0" marL="0">
               <a:buNone/>
             </a:pPr>
             <a:r>
@@ -8715,13 +8445,6 @@
             <a:prstDash val="solid"/>
           </a:ln>
         </p:spPr>
-        <p:txBody>
-          <a:bodyPr/>
-          <a:lstStyle/>
-          <a:p>
-            <a:endParaRPr lang="en-AE"/>
-          </a:p>
-        </p:txBody>
       </p:sp>
       <p:sp>
         <p:nvSpPr>
@@ -8744,7 +8467,7 @@
           <a:bodyPr wrap="square" lIns="0" tIns="0" rIns="0" bIns="0" rtlCol="0" anchor="ctr"/>
           <a:lstStyle/>
           <a:p>
-            <a:pPr marL="0" indent="0">
+            <a:pPr indent="0" marL="0">
               <a:buNone/>
             </a:pPr>
             <a:r>
@@ -8783,7 +8506,7 @@
           <a:bodyPr wrap="square" lIns="0" tIns="0" rIns="0" bIns="0" rtlCol="0" anchor="ctr"/>
           <a:lstStyle/>
           <a:p>
-            <a:pPr marL="0" indent="0">
+            <a:pPr indent="0" marL="0">
               <a:buNone/>
             </a:pPr>
             <a:r>
@@ -8817,7 +8540,6 @@
         <a:solidFill>
           <a:srgbClr val="FAF6F1"/>
         </a:solidFill>
-        <a:effectLst/>
       </p:bgPr>
     </p:bg>
     <p:spTree>
@@ -8853,13 +8575,6 @@
           </a:solidFill>
           <a:ln/>
         </p:spPr>
-        <p:txBody>
-          <a:bodyPr/>
-          <a:lstStyle/>
-          <a:p>
-            <a:endParaRPr lang="en-AE"/>
-          </a:p>
-        </p:txBody>
       </p:sp>
       <p:sp>
         <p:nvSpPr>
@@ -8882,11 +8597,11 @@
           <a:bodyPr wrap="square" rtlCol="0" anchor="ctr"/>
           <a:lstStyle/>
           <a:p>
-            <a:pPr marL="0" indent="0" algn="ctr">
-              <a:buNone/>
-            </a:pPr>
-            <a:r>
-              <a:rPr lang="en-US" sz="800" b="1" kern="0" spc="300" dirty="0">
+            <a:pPr algn="ctr" indent="0" marL="0">
+              <a:buNone/>
+            </a:pPr>
+            <a:r>
+              <a:rPr lang="en-US" sz="800" b="1" spc="300" kern="0" dirty="0">
                 <a:solidFill>
                   <a:srgbClr val="F5EDE0"/>
                 </a:solidFill>
@@ -8921,11 +8636,11 @@
           <a:bodyPr wrap="square" rtlCol="0" anchor="ctr"/>
           <a:lstStyle/>
           <a:p>
-            <a:pPr marL="0" indent="0">
-              <a:buNone/>
-            </a:pPr>
-            <a:r>
-              <a:rPr lang="en-US" sz="900" b="1" kern="0" spc="300" dirty="0">
+            <a:pPr indent="0" marL="0">
+              <a:buNone/>
+            </a:pPr>
+            <a:r>
+              <a:rPr lang="en-US" sz="900" b="1" spc="300" kern="0" dirty="0">
                 <a:solidFill>
                   <a:srgbClr val="006B5E"/>
                 </a:solidFill>
@@ -8961,13 +8676,6 @@
             <a:prstDash val="solid"/>
           </a:ln>
         </p:spPr>
-        <p:txBody>
-          <a:bodyPr/>
-          <a:lstStyle/>
-          <a:p>
-            <a:endParaRPr lang="en-AE"/>
-          </a:p>
-        </p:txBody>
       </p:sp>
       <p:sp>
         <p:nvSpPr>
@@ -8990,7 +8698,7 @@
           <a:bodyPr wrap="square" lIns="0" tIns="0" rIns="0" bIns="0" rtlCol="0" anchor="ctr"/>
           <a:lstStyle/>
           <a:p>
-            <a:pPr marL="0" indent="0">
+            <a:pPr indent="0" marL="0">
               <a:buNone/>
             </a:pPr>
             <a:r>
@@ -9027,13 +8735,6 @@
           </a:solidFill>
           <a:ln/>
         </p:spPr>
-        <p:txBody>
-          <a:bodyPr/>
-          <a:lstStyle/>
-          <a:p>
-            <a:endParaRPr lang="en-AE"/>
-          </a:p>
-        </p:txBody>
       </p:sp>
       <p:sp>
         <p:nvSpPr>
@@ -9056,7 +8757,7 @@
           <a:bodyPr wrap="square" rtlCol="0" anchor="ctr"/>
           <a:lstStyle/>
           <a:p>
-            <a:pPr marL="0" indent="0">
+            <a:pPr indent="0" marL="0">
               <a:buNone/>
             </a:pPr>
             <a:r>
@@ -9095,7 +8796,7 @@
           <a:bodyPr wrap="square" rtlCol="0" anchor="ctr"/>
           <a:lstStyle/>
           <a:p>
-            <a:pPr marL="0" indent="0" algn="r">
+            <a:pPr algn="r" indent="0" marL="0">
               <a:buNone/>
             </a:pPr>
             <a:r>
@@ -9134,7 +8835,7 @@
           <a:bodyPr wrap="square" rtlCol="0" anchor="ctr"/>
           <a:lstStyle/>
           <a:p>
-            <a:pPr marL="0" indent="0">
+            <a:pPr indent="0" marL="0">
               <a:lnSpc>
                 <a:spcPct val="140000"/>
               </a:lnSpc>
@@ -9174,20 +8875,13 @@
           </a:solidFill>
           <a:ln/>
           <a:effectLst>
-            <a:outerShdw blurRad="76200" dist="25400" dir="8100000" algn="bl" rotWithShape="0">
+            <a:outerShdw sx="100000" sy="100000" kx="0" ky="0" algn="bl" rotWithShape="0" blurRad="76200" dist="25400" dir="8100000">
               <a:srgbClr val="000000">
                 <a:alpha val="10000"/>
               </a:srgbClr>
             </a:outerShdw>
           </a:effectLst>
         </p:spPr>
-        <p:txBody>
-          <a:bodyPr/>
-          <a:lstStyle/>
-          <a:p>
-            <a:endParaRPr lang="en-AE"/>
-          </a:p>
-        </p:txBody>
       </p:sp>
       <p:sp>
         <p:nvSpPr>
@@ -9208,13 +8902,6 @@
           </a:solidFill>
           <a:ln/>
         </p:spPr>
-        <p:txBody>
-          <a:bodyPr/>
-          <a:lstStyle/>
-          <a:p>
-            <a:endParaRPr lang="en-AE"/>
-          </a:p>
-        </p:txBody>
       </p:sp>
       <p:sp>
         <p:nvSpPr>
@@ -9237,11 +8924,11 @@
           <a:bodyPr wrap="square" lIns="0" tIns="0" rIns="0" bIns="0" rtlCol="0" anchor="ctr"/>
           <a:lstStyle/>
           <a:p>
-            <a:pPr marL="0" indent="0">
-              <a:buNone/>
-            </a:pPr>
-            <a:r>
-              <a:rPr lang="en-US" sz="800" b="1" kern="0" spc="150" dirty="0">
+            <a:pPr indent="0" marL="0">
+              <a:buNone/>
+            </a:pPr>
+            <a:r>
+              <a:rPr lang="en-US" sz="800" b="1" spc="150" kern="0" dirty="0">
                 <a:solidFill>
                   <a:srgbClr val="5A6B7F"/>
                 </a:solidFill>
@@ -9276,7 +8963,7 @@
           <a:bodyPr wrap="square" lIns="0" tIns="0" rIns="0" bIns="0" rtlCol="0" anchor="ctr"/>
           <a:lstStyle/>
           <a:p>
-            <a:pPr marL="0" indent="0">
+            <a:pPr indent="0" marL="0">
               <a:buNone/>
             </a:pPr>
             <a:r>
@@ -9455,20 +9142,13 @@
           </a:solidFill>
           <a:ln/>
           <a:effectLst>
-            <a:outerShdw blurRad="76200" dist="25400" dir="8100000" algn="bl" rotWithShape="0">
+            <a:outerShdw sx="100000" sy="100000" kx="0" ky="0" algn="bl" rotWithShape="0" blurRad="76200" dist="25400" dir="8100000">
               <a:srgbClr val="000000">
                 <a:alpha val="10000"/>
               </a:srgbClr>
             </a:outerShdw>
           </a:effectLst>
         </p:spPr>
-        <p:txBody>
-          <a:bodyPr/>
-          <a:lstStyle/>
-          <a:p>
-            <a:endParaRPr lang="en-AE"/>
-          </a:p>
-        </p:txBody>
       </p:sp>
       <p:sp>
         <p:nvSpPr>
@@ -9489,13 +9169,6 @@
           </a:solidFill>
           <a:ln/>
         </p:spPr>
-        <p:txBody>
-          <a:bodyPr/>
-          <a:lstStyle/>
-          <a:p>
-            <a:endParaRPr lang="en-AE"/>
-          </a:p>
-        </p:txBody>
       </p:sp>
       <p:sp>
         <p:nvSpPr>
@@ -9518,11 +9191,11 @@
           <a:bodyPr wrap="square" lIns="0" tIns="0" rIns="0" bIns="0" rtlCol="0" anchor="ctr"/>
           <a:lstStyle/>
           <a:p>
-            <a:pPr marL="0" indent="0">
-              <a:buNone/>
-            </a:pPr>
-            <a:r>
-              <a:rPr lang="en-US" sz="800" b="1" kern="0" spc="150" dirty="0">
+            <a:pPr indent="0" marL="0">
+              <a:buNone/>
+            </a:pPr>
+            <a:r>
+              <a:rPr lang="en-US" sz="800" b="1" spc="150" kern="0" dirty="0">
                 <a:solidFill>
                   <a:srgbClr val="5A6B7F"/>
                 </a:solidFill>
@@ -9557,7 +9230,7 @@
           <a:bodyPr wrap="square" lIns="0" tIns="0" rIns="0" bIns="0" rtlCol="0" anchor="ctr"/>
           <a:lstStyle/>
           <a:p>
-            <a:pPr marL="0" indent="0">
+            <a:pPr indent="0" marL="0">
               <a:buNone/>
             </a:pPr>
             <a:r>
@@ -9736,20 +9409,13 @@
           </a:solidFill>
           <a:ln/>
           <a:effectLst>
-            <a:outerShdw blurRad="76200" dist="25400" dir="8100000" algn="bl" rotWithShape="0">
+            <a:outerShdw sx="100000" sy="100000" kx="0" ky="0" algn="bl" rotWithShape="0" blurRad="76200" dist="25400" dir="8100000">
               <a:srgbClr val="000000">
                 <a:alpha val="10000"/>
               </a:srgbClr>
             </a:outerShdw>
           </a:effectLst>
         </p:spPr>
-        <p:txBody>
-          <a:bodyPr/>
-          <a:lstStyle/>
-          <a:p>
-            <a:endParaRPr lang="en-AE"/>
-          </a:p>
-        </p:txBody>
       </p:sp>
       <p:sp>
         <p:nvSpPr>
@@ -9770,13 +9436,6 @@
           </a:solidFill>
           <a:ln/>
         </p:spPr>
-        <p:txBody>
-          <a:bodyPr/>
-          <a:lstStyle/>
-          <a:p>
-            <a:endParaRPr lang="en-AE"/>
-          </a:p>
-        </p:txBody>
       </p:sp>
       <p:sp>
         <p:nvSpPr>
@@ -9799,11 +9458,11 @@
           <a:bodyPr wrap="square" lIns="0" tIns="0" rIns="0" bIns="0" rtlCol="0" anchor="ctr"/>
           <a:lstStyle/>
           <a:p>
-            <a:pPr marL="0" indent="0">
-              <a:buNone/>
-            </a:pPr>
-            <a:r>
-              <a:rPr lang="en-US" sz="800" b="1" kern="0" spc="150" dirty="0">
+            <a:pPr indent="0" marL="0">
+              <a:buNone/>
+            </a:pPr>
+            <a:r>
+              <a:rPr lang="en-US" sz="800" b="1" spc="150" kern="0" dirty="0">
                 <a:solidFill>
                   <a:srgbClr val="5A6B7F"/>
                 </a:solidFill>
@@ -9838,7 +9497,7 @@
           <a:bodyPr wrap="square" lIns="0" tIns="0" rIns="0" bIns="0" rtlCol="0" anchor="ctr"/>
           <a:lstStyle/>
           <a:p>
-            <a:pPr marL="0" indent="0">
+            <a:pPr indent="0" marL="0">
               <a:buNone/>
             </a:pPr>
             <a:r>
@@ -10019,7 +9678,7 @@
           <a:bodyPr wrap="square" rtlCol="0" anchor="ctr"/>
           <a:lstStyle/>
           <a:p>
-            <a:pPr marL="0" indent="0" algn="ctr">
+            <a:pPr algn="ctr" indent="0" marL="0">
               <a:buNone/>
             </a:pPr>
             <a:r>
@@ -10058,7 +9717,7 @@
           <a:bodyPr wrap="square" rtlCol="0" anchor="ctr"/>
           <a:lstStyle/>
           <a:p>
-            <a:pPr marL="0" indent="0" algn="ctr">
+            <a:pPr algn="ctr" indent="0" marL="0">
               <a:buNone/>
             </a:pPr>
             <a:r>
@@ -10092,7 +9751,6 @@
         <a:solidFill>
           <a:srgbClr val="FAF6F1"/>
         </a:solidFill>
-        <a:effectLst/>
       </p:bgPr>
     </p:bg>
     <p:spTree>
@@ -10128,13 +9786,6 @@
           </a:solidFill>
           <a:ln/>
         </p:spPr>
-        <p:txBody>
-          <a:bodyPr/>
-          <a:lstStyle/>
-          <a:p>
-            <a:endParaRPr lang="en-AE"/>
-          </a:p>
-        </p:txBody>
       </p:sp>
       <p:sp>
         <p:nvSpPr>
@@ -10157,11 +9808,11 @@
           <a:bodyPr wrap="square" rtlCol="0" anchor="ctr"/>
           <a:lstStyle/>
           <a:p>
-            <a:pPr marL="0" indent="0" algn="ctr">
-              <a:buNone/>
-            </a:pPr>
-            <a:r>
-              <a:rPr lang="en-US" sz="800" b="1" kern="0" spc="300" dirty="0">
+            <a:pPr algn="ctr" indent="0" marL="0">
+              <a:buNone/>
+            </a:pPr>
+            <a:r>
+              <a:rPr lang="en-US" sz="800" b="1" spc="300" kern="0" dirty="0">
                 <a:solidFill>
                   <a:srgbClr val="F5EDE0"/>
                 </a:solidFill>
@@ -10196,11 +9847,11 @@
           <a:bodyPr wrap="square" rtlCol="0" anchor="ctr"/>
           <a:lstStyle/>
           <a:p>
-            <a:pPr marL="0" indent="0">
-              <a:buNone/>
-            </a:pPr>
-            <a:r>
-              <a:rPr lang="en-US" sz="900" b="1" kern="0" spc="300" dirty="0">
+            <a:pPr indent="0" marL="0">
+              <a:buNone/>
+            </a:pPr>
+            <a:r>
+              <a:rPr lang="en-US" sz="900" b="1" spc="300" kern="0" dirty="0">
                 <a:solidFill>
                   <a:srgbClr val="006B5E"/>
                 </a:solidFill>
@@ -10236,13 +9887,6 @@
             <a:prstDash val="solid"/>
           </a:ln>
         </p:spPr>
-        <p:txBody>
-          <a:bodyPr/>
-          <a:lstStyle/>
-          <a:p>
-            <a:endParaRPr lang="en-AE"/>
-          </a:p>
-        </p:txBody>
       </p:sp>
       <p:sp>
         <p:nvSpPr>
@@ -10265,7 +9909,7 @@
           <a:bodyPr wrap="square" lIns="0" tIns="0" rIns="0" bIns="0" rtlCol="0" anchor="ctr"/>
           <a:lstStyle/>
           <a:p>
-            <a:pPr marL="0" indent="0">
+            <a:pPr indent="0" marL="0">
               <a:buNone/>
             </a:pPr>
             <a:r>
@@ -10302,13 +9946,6 @@
           </a:solidFill>
           <a:ln/>
         </p:spPr>
-        <p:txBody>
-          <a:bodyPr/>
-          <a:lstStyle/>
-          <a:p>
-            <a:endParaRPr lang="en-AE"/>
-          </a:p>
-        </p:txBody>
       </p:sp>
       <p:sp>
         <p:nvSpPr>
@@ -10331,7 +9968,7 @@
           <a:bodyPr wrap="square" rtlCol="0" anchor="ctr"/>
           <a:lstStyle/>
           <a:p>
-            <a:pPr marL="0" indent="0">
+            <a:pPr indent="0" marL="0">
               <a:buNone/>
             </a:pPr>
             <a:r>
@@ -10370,7 +10007,7 @@
           <a:bodyPr wrap="square" rtlCol="0" anchor="ctr"/>
           <a:lstStyle/>
           <a:p>
-            <a:pPr marL="0" indent="0" algn="r">
+            <a:pPr algn="r" indent="0" marL="0">
               <a:buNone/>
             </a:pPr>
             <a:r>
@@ -10407,20 +10044,13 @@
           </a:solidFill>
           <a:ln/>
           <a:effectLst>
-            <a:outerShdw blurRad="76200" dist="25400" dir="8100000" algn="bl" rotWithShape="0">
+            <a:outerShdw sx="100000" sy="100000" kx="0" ky="0" algn="bl" rotWithShape="0" blurRad="76200" dist="25400" dir="8100000">
               <a:srgbClr val="000000">
                 <a:alpha val="10000"/>
               </a:srgbClr>
             </a:outerShdw>
           </a:effectLst>
         </p:spPr>
-        <p:txBody>
-          <a:bodyPr/>
-          <a:lstStyle/>
-          <a:p>
-            <a:endParaRPr lang="en-AE"/>
-          </a:p>
-        </p:txBody>
       </p:sp>
       <p:sp>
         <p:nvSpPr>
@@ -10441,13 +10071,6 @@
           </a:solidFill>
           <a:ln/>
         </p:spPr>
-        <p:txBody>
-          <a:bodyPr/>
-          <a:lstStyle/>
-          <a:p>
-            <a:endParaRPr lang="en-AE"/>
-          </a:p>
-        </p:txBody>
       </p:sp>
       <p:sp>
         <p:nvSpPr>
@@ -10470,7 +10093,7 @@
           <a:bodyPr wrap="square" lIns="0" tIns="0" rIns="0" bIns="0" rtlCol="0" anchor="ctr"/>
           <a:lstStyle/>
           <a:p>
-            <a:pPr marL="0" indent="0">
+            <a:pPr indent="0" marL="0">
               <a:buNone/>
             </a:pPr>
             <a:r>
@@ -10673,20 +10296,13 @@
           </a:solidFill>
           <a:ln/>
           <a:effectLst>
-            <a:outerShdw blurRad="76200" dist="25400" dir="8100000" algn="bl" rotWithShape="0">
+            <a:outerShdw sx="100000" sy="100000" kx="0" ky="0" algn="bl" rotWithShape="0" blurRad="76200" dist="25400" dir="8100000">
               <a:srgbClr val="000000">
                 <a:alpha val="10000"/>
               </a:srgbClr>
             </a:outerShdw>
           </a:effectLst>
         </p:spPr>
-        <p:txBody>
-          <a:bodyPr/>
-          <a:lstStyle/>
-          <a:p>
-            <a:endParaRPr lang="en-AE"/>
-          </a:p>
-        </p:txBody>
       </p:sp>
       <p:sp>
         <p:nvSpPr>
@@ -10707,13 +10323,6 @@
           </a:solidFill>
           <a:ln/>
         </p:spPr>
-        <p:txBody>
-          <a:bodyPr/>
-          <a:lstStyle/>
-          <a:p>
-            <a:endParaRPr lang="en-AE"/>
-          </a:p>
-        </p:txBody>
       </p:sp>
       <p:sp>
         <p:nvSpPr>
@@ -10736,7 +10345,7 @@
           <a:bodyPr wrap="square" lIns="0" tIns="0" rIns="0" bIns="0" rtlCol="0" anchor="ctr"/>
           <a:lstStyle/>
           <a:p>
-            <a:pPr marL="0" indent="0">
+            <a:pPr indent="0" marL="0">
               <a:buNone/>
             </a:pPr>
             <a:r>
@@ -10936,7 +10545,6 @@
         <a:solidFill>
           <a:srgbClr val="0D1B2A"/>
         </a:solidFill>
-        <a:effectLst/>
       </p:bgPr>
     </p:bg>
     <p:spTree>
@@ -10974,13 +10582,6 @@
           </a:solidFill>
           <a:ln/>
         </p:spPr>
-        <p:txBody>
-          <a:bodyPr/>
-          <a:lstStyle/>
-          <a:p>
-            <a:endParaRPr lang="en-AE"/>
-          </a:p>
-        </p:txBody>
       </p:sp>
       <p:sp>
         <p:nvSpPr>
@@ -11003,7 +10604,7 @@
           <a:bodyPr wrap="square" rtlCol="0" anchor="ctr"/>
           <a:lstStyle/>
           <a:p>
-            <a:pPr marL="0" indent="0">
+            <a:pPr indent="0" marL="0">
               <a:buNone/>
             </a:pPr>
             <a:r>
@@ -11017,6 +10618,9 @@
               </a:rPr>
               <a:t>Enterprise</a:t>
             </a:r>
+            <a:pPr indent="0" marL="0">
+              <a:buNone/>
+            </a:pPr>
             <a:r>
               <a:rPr lang="en-US" sz="1400" b="1" dirty="0">
                 <a:solidFill>
@@ -11053,11 +10657,11 @@
           <a:bodyPr wrap="square" rtlCol="0" anchor="ctr"/>
           <a:lstStyle/>
           <a:p>
-            <a:pPr marL="0" indent="0">
-              <a:buNone/>
-            </a:pPr>
-            <a:r>
-              <a:rPr lang="en-US" sz="2400" b="1" kern="0" spc="200" dirty="0">
+            <a:pPr indent="0" marL="0">
+              <a:buNone/>
+            </a:pPr>
+            <a:r>
+              <a:rPr lang="en-US" sz="2400" b="1" spc="200" kern="0" dirty="0">
                 <a:solidFill>
                   <a:srgbClr val="F5EDE0"/>
                 </a:solidFill>
@@ -11092,7 +10696,7 @@
           <a:bodyPr wrap="square" rtlCol="0" anchor="ctr"/>
           <a:lstStyle/>
           <a:p>
-            <a:pPr marL="0" indent="0">
+            <a:pPr indent="0" marL="0">
               <a:lnSpc>
                 <a:spcPct val="150000"/>
               </a:lnSpc>
@@ -11112,7 +10716,7 @@
             <a:endParaRPr lang="en-US" sz="1200" dirty="0"/>
           </a:p>
           <a:p>
-            <a:pPr marL="0" indent="0">
+            <a:pPr indent="0" marL="0">
               <a:lnSpc>
                 <a:spcPct val="150000"/>
               </a:lnSpc>
@@ -11121,7 +10725,7 @@
             <a:endParaRPr lang="en-US" sz="1200" dirty="0"/>
           </a:p>
           <a:p>
-            <a:pPr marL="0" indent="0">
+            <a:pPr indent="0" marL="0">
               <a:lnSpc>
                 <a:spcPct val="150000"/>
               </a:lnSpc>
@@ -11163,7 +10767,7 @@
           <a:bodyPr wrap="square" lIns="0" tIns="0" rIns="0" bIns="0" rtlCol="0" anchor="ctr"/>
           <a:lstStyle/>
           <a:p>
-            <a:pPr marL="0" indent="0">
+            <a:pPr indent="0" marL="0">
               <a:buNone/>
             </a:pPr>
             <a:r>
@@ -11202,7 +10806,7 @@
           <a:bodyPr wrap="square" lIns="0" tIns="0" rIns="0" bIns="0" rtlCol="0" anchor="ctr"/>
           <a:lstStyle/>
           <a:p>
-            <a:pPr marL="0" indent="0">
+            <a:pPr indent="0" marL="0">
               <a:buNone/>
             </a:pPr>
             <a:r>
@@ -11241,7 +10845,7 @@
           <a:bodyPr wrap="square" lIns="0" tIns="0" rIns="0" bIns="0" rtlCol="0" anchor="ctr"/>
           <a:lstStyle/>
           <a:p>
-            <a:pPr marL="0" indent="0">
+            <a:pPr indent="0" marL="0">
               <a:buNone/>
             </a:pPr>
             <a:r>
@@ -11280,7 +10884,7 @@
           <a:bodyPr wrap="square" lIns="0" tIns="0" rIns="0" bIns="0" rtlCol="0" anchor="ctr"/>
           <a:lstStyle/>
           <a:p>
-            <a:pPr marL="0" indent="0">
+            <a:pPr indent="0" marL="0">
               <a:buNone/>
             </a:pPr>
             <a:r>
@@ -11319,7 +10923,7 @@
           <a:bodyPr wrap="square" lIns="0" tIns="0" rIns="0" bIns="0" rtlCol="0" anchor="ctr"/>
           <a:lstStyle/>
           <a:p>
-            <a:pPr marL="0" indent="0">
+            <a:pPr indent="0" marL="0">
               <a:buNone/>
             </a:pPr>
             <a:r>
@@ -11358,7 +10962,7 @@
           <a:bodyPr wrap="square" lIns="0" tIns="0" rIns="0" bIns="0" rtlCol="0" anchor="ctr"/>
           <a:lstStyle/>
           <a:p>
-            <a:pPr marL="0" indent="0">
+            <a:pPr indent="0" marL="0">
               <a:buNone/>
             </a:pPr>
             <a:r>
@@ -11397,13 +11001,6 @@
           </a:solidFill>
           <a:ln/>
         </p:spPr>
-        <p:txBody>
-          <a:bodyPr/>
-          <a:lstStyle/>
-          <a:p>
-            <a:endParaRPr lang="en-AE"/>
-          </a:p>
-        </p:txBody>
       </p:sp>
       <p:sp>
         <p:nvSpPr>
@@ -11426,7 +11023,7 @@
           <a:bodyPr wrap="square" rtlCol="0" anchor="ctr"/>
           <a:lstStyle/>
           <a:p>
-            <a:pPr marL="0" indent="0" algn="ctr">
+            <a:pPr algn="ctr" indent="0" marL="0">
               <a:buNone/>
             </a:pPr>
             <a:r>
@@ -11745,319 +11342,4 @@
     </a:ext>
   </a:extLst>
 </a:theme>
-</file>
-
-<file path=ppt/theme/theme2.xml><?xml version="1.0" encoding="utf-8"?>
-<a:theme xmlns:a="http://schemas.openxmlformats.org/drawingml/2006/main" name="Office Theme">
-  <a:themeElements>
-    <a:clrScheme name="Office">
-      <a:dk1>
-        <a:sysClr val="windowText" lastClr="000000"/>
-      </a:dk1>
-      <a:lt1>
-        <a:sysClr val="window" lastClr="FFFFFF"/>
-      </a:lt1>
-      <a:dk2>
-        <a:srgbClr val="0E2841"/>
-      </a:dk2>
-      <a:lt2>
-        <a:srgbClr val="E8E8E8"/>
-      </a:lt2>
-      <a:accent1>
-        <a:srgbClr val="156082"/>
-      </a:accent1>
-      <a:accent2>
-        <a:srgbClr val="E97132"/>
-      </a:accent2>
-      <a:accent3>
-        <a:srgbClr val="196B24"/>
-      </a:accent3>
-      <a:accent4>
-        <a:srgbClr val="0F9ED5"/>
-      </a:accent4>
-      <a:accent5>
-        <a:srgbClr val="A02B93"/>
-      </a:accent5>
-      <a:accent6>
-        <a:srgbClr val="4EA72E"/>
-      </a:accent6>
-      <a:hlink>
-        <a:srgbClr val="467886"/>
-      </a:hlink>
-      <a:folHlink>
-        <a:srgbClr val="96607D"/>
-      </a:folHlink>
-    </a:clrScheme>
-    <a:fontScheme name="Office">
-      <a:majorFont>
-        <a:latin typeface="Aptos Display" panose="02110004020202020204"/>
-        <a:ea typeface=""/>
-        <a:cs typeface=""/>
-        <a:font script="Jpan" typeface="游ゴシック Light"/>
-        <a:font script="Hang" typeface="맑은 고딕"/>
-        <a:font script="Hans" typeface="等线 Light"/>
-        <a:font script="Hant" typeface="新細明體"/>
-        <a:font script="Arab" typeface="Times New Roman"/>
-        <a:font script="Hebr" typeface="Times New Roman"/>
-        <a:font script="Thai" typeface="Angsana New"/>
-        <a:font script="Ethi" typeface="Nyala"/>
-        <a:font script="Beng" typeface="Vrinda"/>
-        <a:font script="Gujr" typeface="Shruti"/>
-        <a:font script="Khmr" typeface="MoolBoran"/>
-        <a:font script="Knda" typeface="Tunga"/>
-        <a:font script="Guru" typeface="Raavi"/>
-        <a:font script="Cans" typeface="Euphemia"/>
-        <a:font script="Cher" typeface="Plantagenet Cherokee"/>
-        <a:font script="Yiii" typeface="Microsoft Yi Baiti"/>
-        <a:font script="Tibt" typeface="Microsoft Himalaya"/>
-        <a:font script="Thaa" typeface="MV Boli"/>
-        <a:font script="Deva" typeface="Mangal"/>
-        <a:font script="Telu" typeface="Gautami"/>
-        <a:font script="Taml" typeface="Latha"/>
-        <a:font script="Syrc" typeface="Estrangelo Edessa"/>
-        <a:font script="Orya" typeface="Kalinga"/>
-        <a:font script="Mlym" typeface="Kartika"/>
-        <a:font script="Laoo" typeface="DokChampa"/>
-        <a:font script="Sinh" typeface="Iskoola Pota"/>
-        <a:font script="Mong" typeface="Mongolian Baiti"/>
-        <a:font script="Viet" typeface="Times New Roman"/>
-        <a:font script="Uigh" typeface="Microsoft Uighur"/>
-        <a:font script="Geor" typeface="Sylfaen"/>
-        <a:font script="Armn" typeface="Arial"/>
-        <a:font script="Bugi" typeface="Leelawadee UI"/>
-        <a:font script="Bopo" typeface="Microsoft JhengHei"/>
-        <a:font script="Java" typeface="Javanese Text"/>
-        <a:font script="Lisu" typeface="Segoe UI"/>
-        <a:font script="Mymr" typeface="Myanmar Text"/>
-        <a:font script="Nkoo" typeface="Ebrima"/>
-        <a:font script="Olck" typeface="Nirmala UI"/>
-        <a:font script="Osma" typeface="Ebrima"/>
-        <a:font script="Phag" typeface="Phagspa"/>
-        <a:font script="Syrn" typeface="Estrangelo Edessa"/>
-        <a:font script="Syrj" typeface="Estrangelo Edessa"/>
-        <a:font script="Syre" typeface="Estrangelo Edessa"/>
-        <a:font script="Sora" typeface="Nirmala UI"/>
-        <a:font script="Tale" typeface="Microsoft Tai Le"/>
-        <a:font script="Talu" typeface="Microsoft New Tai Lue"/>
-        <a:font script="Tfng" typeface="Ebrima"/>
-      </a:majorFont>
-      <a:minorFont>
-        <a:latin typeface="Aptos" panose="02110004020202020204"/>
-        <a:ea typeface=""/>
-        <a:cs typeface=""/>
-        <a:font script="Jpan" typeface="游ゴシック"/>
-        <a:font script="Hang" typeface="맑은 고딕"/>
-        <a:font script="Hans" typeface="等线"/>
-        <a:font script="Hant" typeface="新細明體"/>
-        <a:font script="Arab" typeface="Arial"/>
-        <a:font script="Hebr" typeface="Arial"/>
-        <a:font script="Thai" typeface="Cordia New"/>
-        <a:font script="Ethi" typeface="Nyala"/>
-        <a:font script="Beng" typeface="Vrinda"/>
-        <a:font script="Gujr" typeface="Shruti"/>
-        <a:font script="Khmr" typeface="DaunPenh"/>
-        <a:font script="Knda" typeface="Tunga"/>
-        <a:font script="Guru" typeface="Raavi"/>
-        <a:font script="Cans" typeface="Euphemia"/>
-        <a:font script="Cher" typeface="Plantagenet Cherokee"/>
-        <a:font script="Yiii" typeface="Microsoft Yi Baiti"/>
-        <a:font script="Tibt" typeface="Microsoft Himalaya"/>
-        <a:font script="Thaa" typeface="MV Boli"/>
-        <a:font script="Deva" typeface="Mangal"/>
-        <a:font script="Telu" typeface="Gautami"/>
-        <a:font script="Taml" typeface="Latha"/>
-        <a:font script="Syrc" typeface="Estrangelo Edessa"/>
-        <a:font script="Orya" typeface="Kalinga"/>
-        <a:font script="Mlym" typeface="Kartika"/>
-        <a:font script="Laoo" typeface="DokChampa"/>
-        <a:font script="Sinh" typeface="Iskoola Pota"/>
-        <a:font script="Mong" typeface="Mongolian Baiti"/>
-        <a:font script="Viet" typeface="Arial"/>
-        <a:font script="Uigh" typeface="Microsoft Uighur"/>
-        <a:font script="Geor" typeface="Sylfaen"/>
-        <a:font script="Armn" typeface="Arial"/>
-        <a:font script="Bugi" typeface="Leelawadee UI"/>
-        <a:font script="Bopo" typeface="Microsoft JhengHei"/>
-        <a:font script="Java" typeface="Javanese Text"/>
-        <a:font script="Lisu" typeface="Segoe UI"/>
-        <a:font script="Mymr" typeface="Myanmar Text"/>
-        <a:font script="Nkoo" typeface="Ebrima"/>
-        <a:font script="Olck" typeface="Nirmala UI"/>
-        <a:font script="Osma" typeface="Ebrima"/>
-        <a:font script="Phag" typeface="Phagspa"/>
-        <a:font script="Syrn" typeface="Estrangelo Edessa"/>
-        <a:font script="Syrj" typeface="Estrangelo Edessa"/>
-        <a:font script="Syre" typeface="Estrangelo Edessa"/>
-        <a:font script="Sora" typeface="Nirmala UI"/>
-        <a:font script="Tale" typeface="Microsoft Tai Le"/>
-        <a:font script="Talu" typeface="Microsoft New Tai Lue"/>
-        <a:font script="Tfng" typeface="Ebrima"/>
-      </a:minorFont>
-    </a:fontScheme>
-    <a:fmtScheme name="Office">
-      <a:fillStyleLst>
-        <a:solidFill>
-          <a:schemeClr val="phClr"/>
-        </a:solidFill>
-        <a:gradFill rotWithShape="1">
-          <a:gsLst>
-            <a:gs pos="0">
-              <a:schemeClr val="phClr">
-                <a:lumMod val="110000"/>
-                <a:satMod val="105000"/>
-                <a:tint val="67000"/>
-              </a:schemeClr>
-            </a:gs>
-            <a:gs pos="50000">
-              <a:schemeClr val="phClr">
-                <a:lumMod val="105000"/>
-                <a:satMod val="103000"/>
-                <a:tint val="73000"/>
-              </a:schemeClr>
-            </a:gs>
-            <a:gs pos="100000">
-              <a:schemeClr val="phClr">
-                <a:lumMod val="105000"/>
-                <a:satMod val="109000"/>
-                <a:tint val="81000"/>
-              </a:schemeClr>
-            </a:gs>
-          </a:gsLst>
-          <a:lin ang="5400000" scaled="0"/>
-        </a:gradFill>
-        <a:gradFill rotWithShape="1">
-          <a:gsLst>
-            <a:gs pos="0">
-              <a:schemeClr val="phClr">
-                <a:satMod val="103000"/>
-                <a:lumMod val="102000"/>
-                <a:tint val="94000"/>
-              </a:schemeClr>
-            </a:gs>
-            <a:gs pos="50000">
-              <a:schemeClr val="phClr">
-                <a:satMod val="110000"/>
-                <a:lumMod val="100000"/>
-                <a:shade val="100000"/>
-              </a:schemeClr>
-            </a:gs>
-            <a:gs pos="100000">
-              <a:schemeClr val="phClr">
-                <a:lumMod val="99000"/>
-                <a:satMod val="120000"/>
-                <a:shade val="78000"/>
-              </a:schemeClr>
-            </a:gs>
-          </a:gsLst>
-          <a:lin ang="5400000" scaled="0"/>
-        </a:gradFill>
-      </a:fillStyleLst>
-      <a:lnStyleLst>
-        <a:ln w="12700" cap="flat" cmpd="sng" algn="ctr">
-          <a:solidFill>
-            <a:schemeClr val="phClr"/>
-          </a:solidFill>
-          <a:prstDash val="solid"/>
-          <a:miter lim="800000"/>
-        </a:ln>
-        <a:ln w="19050" cap="flat" cmpd="sng" algn="ctr">
-          <a:solidFill>
-            <a:schemeClr val="phClr"/>
-          </a:solidFill>
-          <a:prstDash val="solid"/>
-          <a:miter lim="800000"/>
-        </a:ln>
-        <a:ln w="25400" cap="flat" cmpd="sng" algn="ctr">
-          <a:solidFill>
-            <a:schemeClr val="phClr"/>
-          </a:solidFill>
-          <a:prstDash val="solid"/>
-          <a:miter lim="800000"/>
-        </a:ln>
-      </a:lnStyleLst>
-      <a:effectStyleLst>
-        <a:effectStyle>
-          <a:effectLst/>
-        </a:effectStyle>
-        <a:effectStyle>
-          <a:effectLst/>
-        </a:effectStyle>
-        <a:effectStyle>
-          <a:effectLst>
-            <a:outerShdw blurRad="57150" dist="19050" dir="5400000" algn="ctr" rotWithShape="0">
-              <a:srgbClr val="000000">
-                <a:alpha val="63000"/>
-              </a:srgbClr>
-            </a:outerShdw>
-          </a:effectLst>
-        </a:effectStyle>
-      </a:effectStyleLst>
-      <a:bgFillStyleLst>
-        <a:solidFill>
-          <a:schemeClr val="phClr"/>
-        </a:solidFill>
-        <a:solidFill>
-          <a:schemeClr val="phClr">
-            <a:tint val="95000"/>
-            <a:satMod val="170000"/>
-          </a:schemeClr>
-        </a:solidFill>
-        <a:gradFill rotWithShape="1">
-          <a:gsLst>
-            <a:gs pos="0">
-              <a:schemeClr val="phClr">
-                <a:tint val="93000"/>
-                <a:satMod val="150000"/>
-                <a:shade val="98000"/>
-                <a:lumMod val="102000"/>
-              </a:schemeClr>
-            </a:gs>
-            <a:gs pos="50000">
-              <a:schemeClr val="phClr">
-                <a:tint val="98000"/>
-                <a:satMod val="130000"/>
-                <a:shade val="90000"/>
-                <a:lumMod val="103000"/>
-              </a:schemeClr>
-            </a:gs>
-            <a:gs pos="100000">
-              <a:schemeClr val="phClr">
-                <a:shade val="63000"/>
-                <a:satMod val="120000"/>
-              </a:schemeClr>
-            </a:gs>
-          </a:gsLst>
-          <a:lin ang="5400000" scaled="0"/>
-        </a:gradFill>
-      </a:bgFillStyleLst>
-    </a:fmtScheme>
-  </a:themeElements>
-  <a:objectDefaults>
-    <a:lnDef>
-      <a:spPr/>
-      <a:bodyPr/>
-      <a:lstStyle/>
-      <a:style>
-        <a:lnRef idx="2">
-          <a:schemeClr val="accent1"/>
-        </a:lnRef>
-        <a:fillRef idx="0">
-          <a:schemeClr val="accent1"/>
-        </a:fillRef>
-        <a:effectRef idx="1">
-          <a:schemeClr val="accent1"/>
-        </a:effectRef>
-        <a:fontRef idx="minor">
-          <a:schemeClr val="tx1"/>
-        </a:fontRef>
-      </a:style>
-    </a:lnDef>
-  </a:objectDefaults>
-  <a:extraClrSchemeLst/>
-  <a:extLst>
-    <a:ext uri="{05A4C25C-085E-4340-85A3-A5531E510DB2}">
-      <thm15:themeFamily xmlns:thm15="http://schemas.microsoft.com/office/thememl/2012/main" name="Office Theme" id="{2E142A2C-CD16-42D6-873A-C26D2A0506FA}" vid="{1BDDFF52-6CD6-40A5-AB3C-68EB2F1E4D0A}"/>
-    </a:ext>
-  </a:extLst>
-</a:theme>
 </file>
</xml_diff>